<commit_message>
Add architecture + agent skills slides to deck
</commit_message>
<xml_diff>
--- a/docs/presentation/agent-austin.pptx
+++ b/docs/presentation/agent-austin.pptx
@@ -8,6 +8,9 @@
     <p:sldId id="256" r:id="rId7"/>
     <p:sldId id="257" r:id="rId8"/>
     <p:sldId id="258" r:id="rId9"/>
+    <p:sldId id="259" r:id="rId10"/>
+    <p:sldId id="260" r:id="rId11"/>
+    <p:sldId id="261" r:id="rId12"/>
   </p:sldIdLst>
   <p:sldSz cx="12191695" cy="6858000" type="screen4x3"/>
   <p:notesSz cx="6858000" cy="9144000"/>
@@ -4213,7 +4216,7 @@
                 </a:solidFill>
                 <a:latin typeface="Calibri"/>
               </a:rPr>
-              <a:t>2 / 3</a:t>
+              <a:t>2 / 6</a:t>
             </a:r>
           </a:p>
         </p:txBody>
@@ -4889,7 +4892,3639 @@
                 </a:solidFill>
                 <a:latin typeface="Calibri"/>
               </a:rPr>
-              <a:t>3 / 3</a:t>
+              <a:t>3 / 6</a:t>
+            </a:r>
+          </a:p>
+        </p:txBody>
+      </p:sp>
+    </p:spTree>
+  </p:cSld>
+  <p:clrMapOvr>
+    <a:masterClrMapping/>
+  </p:clrMapOvr>
+</p:sld>
+</file>
+
+<file path=ppt/slides/slide4.xml><?xml version="1.0" encoding="utf-8"?>
+<p:sld xmlns:a="http://schemas.openxmlformats.org/drawingml/2006/main" xmlns:p="http://schemas.openxmlformats.org/presentationml/2006/main" xmlns:r="http://schemas.openxmlformats.org/officeDocument/2006/relationships">
+  <p:cSld>
+    <p:spTree>
+      <p:nvGrpSpPr>
+        <p:cNvPr id="1" name=""/>
+        <p:cNvGrpSpPr/>
+        <p:nvPr/>
+      </p:nvGrpSpPr>
+      <p:grpSpPr/>
+      <p:sp>
+        <p:nvSpPr>
+          <p:cNvPr id="2" name="Rectangle 1"/>
+          <p:cNvSpPr/>
+          <p:nvPr/>
+        </p:nvSpPr>
+        <p:spPr>
+          <a:xfrm>
+            <a:off x="0" y="0"/>
+            <a:ext cx="12191695" cy="6858000"/>
+          </a:xfrm>
+          <a:prstGeom prst="rect">
+            <a:avLst/>
+          </a:prstGeom>
+          <a:solidFill>
+            <a:srgbClr val="1A1A2E"/>
+          </a:solidFill>
+          <a:ln>
+            <a:noFill/>
+          </a:ln>
+          <a:effectLst/>
+        </p:spPr>
+        <p:style>
+          <a:lnRef idx="1">
+            <a:schemeClr val="accent1"/>
+          </a:lnRef>
+          <a:fillRef idx="3">
+            <a:schemeClr val="accent1"/>
+          </a:fillRef>
+          <a:effectRef idx="2">
+            <a:schemeClr val="accent1"/>
+          </a:effectRef>
+          <a:fontRef idx="minor">
+            <a:schemeClr val="lt1"/>
+          </a:fontRef>
+        </p:style>
+        <p:txBody>
+          <a:bodyPr rtlCol="0" anchor="ctr"/>
+          <a:lstStyle/>
+          <a:p>
+            <a:pPr algn="ctr"/>
+          </a:p>
+        </p:txBody>
+      </p:sp>
+      <p:sp>
+        <p:nvSpPr>
+          <p:cNvPr id="3" name="Rectangle 2"/>
+          <p:cNvSpPr/>
+          <p:nvPr/>
+        </p:nvSpPr>
+        <p:spPr>
+          <a:xfrm>
+            <a:off x="548640" y="548640"/>
+            <a:ext cx="109728" cy="457200"/>
+          </a:xfrm>
+          <a:prstGeom prst="rect">
+            <a:avLst/>
+          </a:prstGeom>
+          <a:solidFill>
+            <a:srgbClr val="00D2FF"/>
+          </a:solidFill>
+          <a:ln>
+            <a:noFill/>
+          </a:ln>
+        </p:spPr>
+        <p:style>
+          <a:lnRef idx="1">
+            <a:schemeClr val="accent1"/>
+          </a:lnRef>
+          <a:fillRef idx="3">
+            <a:schemeClr val="accent1"/>
+          </a:fillRef>
+          <a:effectRef idx="2">
+            <a:schemeClr val="accent1"/>
+          </a:effectRef>
+          <a:fontRef idx="minor">
+            <a:schemeClr val="lt1"/>
+          </a:fontRef>
+        </p:style>
+        <p:txBody>
+          <a:bodyPr rtlCol="0" anchor="ctr"/>
+          <a:lstStyle/>
+          <a:p>
+            <a:pPr algn="ctr"/>
+          </a:p>
+        </p:txBody>
+      </p:sp>
+      <p:sp>
+        <p:nvSpPr>
+          <p:cNvPr id="4" name="TextBox 3"/>
+          <p:cNvSpPr txBox="1"/>
+          <p:nvPr/>
+        </p:nvSpPr>
+        <p:spPr>
+          <a:xfrm>
+            <a:off x="777240" y="502920"/>
+            <a:ext cx="10972800" cy="640080"/>
+          </a:xfrm>
+          <a:prstGeom prst="rect">
+            <a:avLst/>
+          </a:prstGeom>
+          <a:noFill/>
+        </p:spPr>
+        <p:txBody>
+          <a:bodyPr wrap="square" lIns="0" rIns="0" tIns="0" bIns="0">
+            <a:spAutoFit/>
+          </a:bodyPr>
+          <a:lstStyle/>
+          <a:p>
+            <a:pPr algn="l"/>
+            <a:r>
+              <a:rPr sz="3600" b="1">
+                <a:solidFill>
+                  <a:srgbClr val="FFFFFF"/>
+                </a:solidFill>
+                <a:latin typeface="Calibri"/>
+              </a:rPr>
+              <a:t>Architecture</a:t>
+            </a:r>
+          </a:p>
+        </p:txBody>
+      </p:sp>
+      <p:sp>
+        <p:nvSpPr>
+          <p:cNvPr id="5" name="TextBox 4"/>
+          <p:cNvSpPr txBox="1"/>
+          <p:nvPr/>
+        </p:nvSpPr>
+        <p:spPr>
+          <a:xfrm>
+            <a:off x="777240" y="1097280"/>
+            <a:ext cx="10972800" cy="365760"/>
+          </a:xfrm>
+          <a:prstGeom prst="rect">
+            <a:avLst/>
+          </a:prstGeom>
+          <a:noFill/>
+        </p:spPr>
+        <p:txBody>
+          <a:bodyPr wrap="square" lIns="0" rIns="0" tIns="0" bIns="0">
+            <a:spAutoFit/>
+          </a:bodyPr>
+          <a:lstStyle/>
+          <a:p>
+            <a:pPr algn="l"/>
+            <a:r>
+              <a:rPr sz="1400" b="0">
+                <a:solidFill>
+                  <a:srgbClr val="9999AA"/>
+                </a:solidFill>
+                <a:latin typeface="Calibri"/>
+              </a:rPr>
+              <a:t>Browser → Next.js → FastAPI → Claude Agent SDK, backed by Postgres, a volume, and Socrata.</a:t>
+            </a:r>
+          </a:p>
+        </p:txBody>
+      </p:sp>
+      <p:sp>
+        <p:nvSpPr>
+          <p:cNvPr id="6" name="Rounded Rectangle 5"/>
+          <p:cNvSpPr/>
+          <p:nvPr/>
+        </p:nvSpPr>
+        <p:spPr>
+          <a:xfrm>
+            <a:off x="548640" y="1737360"/>
+            <a:ext cx="2377440" cy="4206240"/>
+          </a:xfrm>
+          <a:prstGeom prst="roundRect">
+            <a:avLst>
+              <a:gd name="adj" fmla="val 4000"/>
+            </a:avLst>
+          </a:prstGeom>
+          <a:noFill/>
+          <a:ln w="15875">
+            <a:solidFill>
+              <a:srgbClr val="FF6B6B"/>
+            </a:solidFill>
+            <a:prstDash val="lgDash"/>
+          </a:ln>
+          <a:effectLst/>
+        </p:spPr>
+        <p:style>
+          <a:lnRef idx="1">
+            <a:schemeClr val="accent1"/>
+          </a:lnRef>
+          <a:fillRef idx="3">
+            <a:schemeClr val="accent1"/>
+          </a:fillRef>
+          <a:effectRef idx="2">
+            <a:schemeClr val="accent1"/>
+          </a:effectRef>
+          <a:fontRef idx="minor">
+            <a:schemeClr val="lt1"/>
+          </a:fontRef>
+        </p:style>
+        <p:txBody>
+          <a:bodyPr rtlCol="0" anchor="ctr"/>
+          <a:lstStyle/>
+          <a:p>
+            <a:pPr algn="ctr"/>
+          </a:p>
+        </p:txBody>
+      </p:sp>
+      <p:sp>
+        <p:nvSpPr>
+          <p:cNvPr id="7" name="TextBox 6"/>
+          <p:cNvSpPr txBox="1"/>
+          <p:nvPr/>
+        </p:nvSpPr>
+        <p:spPr>
+          <a:xfrm>
+            <a:off x="731520" y="1810512"/>
+            <a:ext cx="2377440" cy="320040"/>
+          </a:xfrm>
+          <a:prstGeom prst="rect">
+            <a:avLst/>
+          </a:prstGeom>
+          <a:noFill/>
+        </p:spPr>
+        <p:txBody>
+          <a:bodyPr wrap="square" lIns="0" rIns="0" tIns="0" bIns="0">
+            <a:spAutoFit/>
+          </a:bodyPr>
+          <a:lstStyle/>
+          <a:p>
+            <a:pPr algn="l"/>
+            <a:r>
+              <a:rPr sz="1200" b="1">
+                <a:solidFill>
+                  <a:srgbClr val="FF6B6B"/>
+                </a:solidFill>
+                <a:latin typeface="Calibri"/>
+              </a:rPr>
+              <a:t>USER BROWSER</a:t>
+            </a:r>
+          </a:p>
+        </p:txBody>
+      </p:sp>
+      <p:sp>
+        <p:nvSpPr>
+          <p:cNvPr id="8" name="Rounded Rectangle 7"/>
+          <p:cNvSpPr/>
+          <p:nvPr/>
+        </p:nvSpPr>
+        <p:spPr>
+          <a:xfrm>
+            <a:off x="777240" y="3291840"/>
+            <a:ext cx="1920240" cy="914400"/>
+          </a:xfrm>
+          <a:prstGeom prst="roundRect">
+            <a:avLst>
+              <a:gd name="adj" fmla="val 25000"/>
+            </a:avLst>
+          </a:prstGeom>
+          <a:solidFill>
+            <a:srgbClr val="16213E"/>
+          </a:solidFill>
+          <a:ln w="9525">
+            <a:solidFill>
+              <a:srgbClr val="00D2FF"/>
+            </a:solidFill>
+          </a:ln>
+          <a:effectLst/>
+        </p:spPr>
+        <p:style>
+          <a:lnRef idx="1">
+            <a:schemeClr val="accent1"/>
+          </a:lnRef>
+          <a:fillRef idx="3">
+            <a:schemeClr val="accent1"/>
+          </a:fillRef>
+          <a:effectRef idx="2">
+            <a:schemeClr val="accent1"/>
+          </a:effectRef>
+          <a:fontRef idx="minor">
+            <a:schemeClr val="lt1"/>
+          </a:fontRef>
+        </p:style>
+        <p:txBody>
+          <a:bodyPr rtlCol="0" anchor="ctr" lIns="0" rIns="0" tIns="0" bIns="0" wrap="square"/>
+          <a:lstStyle/>
+          <a:p>
+            <a:pPr algn="ctr"/>
+            <a:r>
+              <a:rPr sz="1200" b="1">
+                <a:solidFill>
+                  <a:srgbClr val="FFFFFF"/>
+                </a:solidFill>
+                <a:latin typeface="Calibri"/>
+              </a:rPr>
+              <a:t>Next.js 16 UI</a:t>
+            </a:r>
+          </a:p>
+          <a:p>
+            <a:pPr algn="ctr"/>
+            <a:r>
+              <a:rPr sz="1200" b="1">
+                <a:solidFill>
+                  <a:srgbClr val="FFFFFF"/>
+                </a:solidFill>
+                <a:latin typeface="Calibri"/>
+              </a:rPr>
+              <a:t>AI Elements + shadcn</a:t>
+            </a:r>
+          </a:p>
+        </p:txBody>
+      </p:sp>
+      <p:sp>
+        <p:nvSpPr>
+          <p:cNvPr id="9" name="Rounded Rectangle 8"/>
+          <p:cNvSpPr/>
+          <p:nvPr/>
+        </p:nvSpPr>
+        <p:spPr>
+          <a:xfrm>
+            <a:off x="3200400" y="1737360"/>
+            <a:ext cx="5760720" cy="4206240"/>
+          </a:xfrm>
+          <a:prstGeom prst="roundRect">
+            <a:avLst>
+              <a:gd name="adj" fmla="val 4000"/>
+            </a:avLst>
+          </a:prstGeom>
+          <a:noFill/>
+          <a:ln w="15875">
+            <a:solidFill>
+              <a:srgbClr val="00D2FF"/>
+            </a:solidFill>
+            <a:prstDash val="lgDash"/>
+          </a:ln>
+          <a:effectLst/>
+        </p:spPr>
+        <p:style>
+          <a:lnRef idx="1">
+            <a:schemeClr val="accent1"/>
+          </a:lnRef>
+          <a:fillRef idx="3">
+            <a:schemeClr val="accent1"/>
+          </a:fillRef>
+          <a:effectRef idx="2">
+            <a:schemeClr val="accent1"/>
+          </a:effectRef>
+          <a:fontRef idx="minor">
+            <a:schemeClr val="lt1"/>
+          </a:fontRef>
+        </p:style>
+        <p:txBody>
+          <a:bodyPr rtlCol="0" anchor="ctr"/>
+          <a:lstStyle/>
+          <a:p>
+            <a:pPr algn="ctr"/>
+          </a:p>
+        </p:txBody>
+      </p:sp>
+      <p:sp>
+        <p:nvSpPr>
+          <p:cNvPr id="10" name="TextBox 9"/>
+          <p:cNvSpPr txBox="1"/>
+          <p:nvPr/>
+        </p:nvSpPr>
+        <p:spPr>
+          <a:xfrm>
+            <a:off x="3383280" y="1810512"/>
+            <a:ext cx="5760720" cy="320040"/>
+          </a:xfrm>
+          <a:prstGeom prst="rect">
+            <a:avLst/>
+          </a:prstGeom>
+          <a:noFill/>
+        </p:spPr>
+        <p:txBody>
+          <a:bodyPr wrap="square" lIns="0" rIns="0" tIns="0" bIns="0">
+            <a:spAutoFit/>
+          </a:bodyPr>
+          <a:lstStyle/>
+          <a:p>
+            <a:pPr algn="l"/>
+            <a:r>
+              <a:rPr sz="1200" b="1">
+                <a:solidFill>
+                  <a:srgbClr val="00D2FF"/>
+                </a:solidFill>
+                <a:latin typeface="Calibri"/>
+              </a:rPr>
+              <a:t>RAILWAY PLATFORM</a:t>
+            </a:r>
+          </a:p>
+        </p:txBody>
+      </p:sp>
+      <p:sp>
+        <p:nvSpPr>
+          <p:cNvPr id="11" name="Rounded Rectangle 10"/>
+          <p:cNvSpPr/>
+          <p:nvPr/>
+        </p:nvSpPr>
+        <p:spPr>
+          <a:xfrm>
+            <a:off x="3383280" y="2194560"/>
+            <a:ext cx="2651760" cy="1188720"/>
+          </a:xfrm>
+          <a:prstGeom prst="roundRect">
+            <a:avLst>
+              <a:gd name="adj" fmla="val 4000"/>
+            </a:avLst>
+          </a:prstGeom>
+          <a:noFill/>
+          <a:ln w="15875">
+            <a:solidFill>
+              <a:srgbClr val="7B2FF7"/>
+            </a:solidFill>
+            <a:prstDash val="lgDash"/>
+          </a:ln>
+          <a:effectLst/>
+        </p:spPr>
+        <p:style>
+          <a:lnRef idx="1">
+            <a:schemeClr val="accent1"/>
+          </a:lnRef>
+          <a:fillRef idx="3">
+            <a:schemeClr val="accent1"/>
+          </a:fillRef>
+          <a:effectRef idx="2">
+            <a:schemeClr val="accent1"/>
+          </a:effectRef>
+          <a:fontRef idx="minor">
+            <a:schemeClr val="lt1"/>
+          </a:fontRef>
+        </p:style>
+        <p:txBody>
+          <a:bodyPr rtlCol="0" anchor="ctr"/>
+          <a:lstStyle/>
+          <a:p>
+            <a:pPr algn="ctr"/>
+          </a:p>
+        </p:txBody>
+      </p:sp>
+      <p:sp>
+        <p:nvSpPr>
+          <p:cNvPr id="12" name="TextBox 11"/>
+          <p:cNvSpPr txBox="1"/>
+          <p:nvPr/>
+        </p:nvSpPr>
+        <p:spPr>
+          <a:xfrm>
+            <a:off x="3566160" y="2267712"/>
+            <a:ext cx="2651760" cy="320040"/>
+          </a:xfrm>
+          <a:prstGeom prst="rect">
+            <a:avLst/>
+          </a:prstGeom>
+          <a:noFill/>
+        </p:spPr>
+        <p:txBody>
+          <a:bodyPr wrap="square" lIns="0" rIns="0" tIns="0" bIns="0">
+            <a:spAutoFit/>
+          </a:bodyPr>
+          <a:lstStyle/>
+          <a:p>
+            <a:pPr algn="l"/>
+            <a:r>
+              <a:rPr sz="1200" b="1">
+                <a:solidFill>
+                  <a:srgbClr val="7B2FF7"/>
+                </a:solidFill>
+                <a:latin typeface="Calibri"/>
+              </a:rPr>
+              <a:t>Frontend service</a:t>
+            </a:r>
+          </a:p>
+        </p:txBody>
+      </p:sp>
+      <p:sp>
+        <p:nvSpPr>
+          <p:cNvPr id="13" name="Rounded Rectangle 12"/>
+          <p:cNvSpPr/>
+          <p:nvPr/>
+        </p:nvSpPr>
+        <p:spPr>
+          <a:xfrm>
+            <a:off x="3520440" y="2606040"/>
+            <a:ext cx="2377440" cy="640080"/>
+          </a:xfrm>
+          <a:prstGeom prst="roundRect">
+            <a:avLst>
+              <a:gd name="adj" fmla="val 25000"/>
+            </a:avLst>
+          </a:prstGeom>
+          <a:solidFill>
+            <a:srgbClr val="16213E"/>
+          </a:solidFill>
+          <a:ln w="9525">
+            <a:solidFill>
+              <a:srgbClr val="00D2FF"/>
+            </a:solidFill>
+          </a:ln>
+          <a:effectLst/>
+        </p:spPr>
+        <p:style>
+          <a:lnRef idx="1">
+            <a:schemeClr val="accent1"/>
+          </a:lnRef>
+          <a:fillRef idx="3">
+            <a:schemeClr val="accent1"/>
+          </a:fillRef>
+          <a:effectRef idx="2">
+            <a:schemeClr val="accent1"/>
+          </a:effectRef>
+          <a:fontRef idx="minor">
+            <a:schemeClr val="lt1"/>
+          </a:fontRef>
+        </p:style>
+        <p:txBody>
+          <a:bodyPr rtlCol="0" anchor="ctr" lIns="0" rIns="0" tIns="0" bIns="0" wrap="square"/>
+          <a:lstStyle/>
+          <a:p>
+            <a:pPr algn="ctr"/>
+            <a:r>
+              <a:rPr sz="1200" b="1">
+                <a:solidFill>
+                  <a:srgbClr val="FFFFFF"/>
+                </a:solidFill>
+                <a:latin typeface="Calibri"/>
+              </a:rPr>
+              <a:t>Next.js App Router</a:t>
+            </a:r>
+          </a:p>
+        </p:txBody>
+      </p:sp>
+      <p:sp>
+        <p:nvSpPr>
+          <p:cNvPr id="14" name="Rounded Rectangle 13"/>
+          <p:cNvSpPr/>
+          <p:nvPr/>
+        </p:nvSpPr>
+        <p:spPr>
+          <a:xfrm>
+            <a:off x="6172200" y="2194560"/>
+            <a:ext cx="2651760" cy="3566160"/>
+          </a:xfrm>
+          <a:prstGeom prst="roundRect">
+            <a:avLst>
+              <a:gd name="adj" fmla="val 4000"/>
+            </a:avLst>
+          </a:prstGeom>
+          <a:noFill/>
+          <a:ln w="15875">
+            <a:solidFill>
+              <a:srgbClr val="7B2FF7"/>
+            </a:solidFill>
+            <a:prstDash val="lgDash"/>
+          </a:ln>
+          <a:effectLst/>
+        </p:spPr>
+        <p:style>
+          <a:lnRef idx="1">
+            <a:schemeClr val="accent1"/>
+          </a:lnRef>
+          <a:fillRef idx="3">
+            <a:schemeClr val="accent1"/>
+          </a:fillRef>
+          <a:effectRef idx="2">
+            <a:schemeClr val="accent1"/>
+          </a:effectRef>
+          <a:fontRef idx="minor">
+            <a:schemeClr val="lt1"/>
+          </a:fontRef>
+        </p:style>
+        <p:txBody>
+          <a:bodyPr rtlCol="0" anchor="ctr"/>
+          <a:lstStyle/>
+          <a:p>
+            <a:pPr algn="ctr"/>
+          </a:p>
+        </p:txBody>
+      </p:sp>
+      <p:sp>
+        <p:nvSpPr>
+          <p:cNvPr id="15" name="TextBox 14"/>
+          <p:cNvSpPr txBox="1"/>
+          <p:nvPr/>
+        </p:nvSpPr>
+        <p:spPr>
+          <a:xfrm>
+            <a:off x="6355080" y="2267712"/>
+            <a:ext cx="2651760" cy="320040"/>
+          </a:xfrm>
+          <a:prstGeom prst="rect">
+            <a:avLst/>
+          </a:prstGeom>
+          <a:noFill/>
+        </p:spPr>
+        <p:txBody>
+          <a:bodyPr wrap="square" lIns="0" rIns="0" tIns="0" bIns="0">
+            <a:spAutoFit/>
+          </a:bodyPr>
+          <a:lstStyle/>
+          <a:p>
+            <a:pPr algn="l"/>
+            <a:r>
+              <a:rPr sz="1200" b="1">
+                <a:solidFill>
+                  <a:srgbClr val="7B2FF7"/>
+                </a:solidFill>
+                <a:latin typeface="Calibri"/>
+              </a:rPr>
+              <a:t>Backend service</a:t>
+            </a:r>
+          </a:p>
+        </p:txBody>
+      </p:sp>
+      <p:sp>
+        <p:nvSpPr>
+          <p:cNvPr id="16" name="Rounded Rectangle 15"/>
+          <p:cNvSpPr/>
+          <p:nvPr/>
+        </p:nvSpPr>
+        <p:spPr>
+          <a:xfrm>
+            <a:off x="6309360" y="2606040"/>
+            <a:ext cx="2377440" cy="548640"/>
+          </a:xfrm>
+          <a:prstGeom prst="roundRect">
+            <a:avLst>
+              <a:gd name="adj" fmla="val 25000"/>
+            </a:avLst>
+          </a:prstGeom>
+          <a:solidFill>
+            <a:srgbClr val="16213E"/>
+          </a:solidFill>
+          <a:ln w="9525">
+            <a:solidFill>
+              <a:srgbClr val="00D2FF"/>
+            </a:solidFill>
+          </a:ln>
+          <a:effectLst/>
+        </p:spPr>
+        <p:style>
+          <a:lnRef idx="1">
+            <a:schemeClr val="accent1"/>
+          </a:lnRef>
+          <a:fillRef idx="3">
+            <a:schemeClr val="accent1"/>
+          </a:fillRef>
+          <a:effectRef idx="2">
+            <a:schemeClr val="accent1"/>
+          </a:effectRef>
+          <a:fontRef idx="minor">
+            <a:schemeClr val="lt1"/>
+          </a:fontRef>
+        </p:style>
+        <p:txBody>
+          <a:bodyPr rtlCol="0" anchor="ctr" lIns="0" rIns="0" tIns="0" bIns="0" wrap="square"/>
+          <a:lstStyle/>
+          <a:p>
+            <a:pPr algn="ctr"/>
+            <a:r>
+              <a:rPr sz="1200" b="1">
+                <a:solidFill>
+                  <a:srgbClr val="FFFFFF"/>
+                </a:solidFill>
+                <a:latin typeface="Calibri"/>
+              </a:rPr>
+              <a:t>FastAPI + uvicorn</a:t>
+            </a:r>
+          </a:p>
+        </p:txBody>
+      </p:sp>
+      <p:sp>
+        <p:nvSpPr>
+          <p:cNvPr id="17" name="Rounded Rectangle 16"/>
+          <p:cNvSpPr/>
+          <p:nvPr/>
+        </p:nvSpPr>
+        <p:spPr>
+          <a:xfrm>
+            <a:off x="6309360" y="3246120"/>
+            <a:ext cx="2377440" cy="548640"/>
+          </a:xfrm>
+          <a:prstGeom prst="roundRect">
+            <a:avLst>
+              <a:gd name="adj" fmla="val 25000"/>
+            </a:avLst>
+          </a:prstGeom>
+          <a:solidFill>
+            <a:srgbClr val="0F3460"/>
+          </a:solidFill>
+          <a:ln w="9525">
+            <a:solidFill>
+              <a:srgbClr val="00D2FF"/>
+            </a:solidFill>
+          </a:ln>
+          <a:effectLst/>
+        </p:spPr>
+        <p:style>
+          <a:lnRef idx="1">
+            <a:schemeClr val="accent1"/>
+          </a:lnRef>
+          <a:fillRef idx="3">
+            <a:schemeClr val="accent1"/>
+          </a:fillRef>
+          <a:effectRef idx="2">
+            <a:schemeClr val="accent1"/>
+          </a:effectRef>
+          <a:fontRef idx="minor">
+            <a:schemeClr val="lt1"/>
+          </a:fontRef>
+        </p:style>
+        <p:txBody>
+          <a:bodyPr rtlCol="0" anchor="ctr" lIns="0" rIns="0" tIns="0" bIns="0" wrap="square"/>
+          <a:lstStyle/>
+          <a:p>
+            <a:pPr algn="ctr"/>
+            <a:r>
+              <a:rPr sz="1200" b="1">
+                <a:solidFill>
+                  <a:srgbClr val="FFFFFF"/>
+                </a:solidFill>
+                <a:latin typeface="Calibri"/>
+              </a:rPr>
+              <a:t>Claude Agent SDK</a:t>
+            </a:r>
+          </a:p>
+        </p:txBody>
+      </p:sp>
+      <p:sp>
+        <p:nvSpPr>
+          <p:cNvPr id="18" name="Rounded Rectangle 17"/>
+          <p:cNvSpPr/>
+          <p:nvPr/>
+        </p:nvSpPr>
+        <p:spPr>
+          <a:xfrm>
+            <a:off x="6309360" y="3886200"/>
+            <a:ext cx="2377440" cy="548640"/>
+          </a:xfrm>
+          <a:prstGeom prst="roundRect">
+            <a:avLst>
+              <a:gd name="adj" fmla="val 25000"/>
+            </a:avLst>
+          </a:prstGeom>
+          <a:solidFill>
+            <a:srgbClr val="0F3460"/>
+          </a:solidFill>
+          <a:ln w="9525">
+            <a:solidFill>
+              <a:srgbClr val="00D2FF"/>
+            </a:solidFill>
+          </a:ln>
+          <a:effectLst/>
+        </p:spPr>
+        <p:style>
+          <a:lnRef idx="1">
+            <a:schemeClr val="accent1"/>
+          </a:lnRef>
+          <a:fillRef idx="3">
+            <a:schemeClr val="accent1"/>
+          </a:fillRef>
+          <a:effectRef idx="2">
+            <a:schemeClr val="accent1"/>
+          </a:effectRef>
+          <a:fontRef idx="minor">
+            <a:schemeClr val="lt1"/>
+          </a:fontRef>
+        </p:style>
+        <p:txBody>
+          <a:bodyPr rtlCol="0" anchor="ctr" lIns="0" rIns="0" tIns="0" bIns="0" wrap="square"/>
+          <a:lstStyle/>
+          <a:p>
+            <a:pPr algn="ctr"/>
+            <a:r>
+              <a:rPr sz="1200" b="1">
+                <a:solidFill>
+                  <a:srgbClr val="FFFFFF"/>
+                </a:solidFill>
+                <a:latin typeface="Calibri"/>
+              </a:rPr>
+              <a:t>In-process MCP server</a:t>
+            </a:r>
+          </a:p>
+        </p:txBody>
+      </p:sp>
+      <p:sp>
+        <p:nvSpPr>
+          <p:cNvPr id="19" name="Rounded Rectangle 18"/>
+          <p:cNvSpPr/>
+          <p:nvPr/>
+        </p:nvSpPr>
+        <p:spPr>
+          <a:xfrm>
+            <a:off x="3520440" y="5029200"/>
+            <a:ext cx="2377440" cy="640080"/>
+          </a:xfrm>
+          <a:prstGeom prst="roundRect">
+            <a:avLst>
+              <a:gd name="adj" fmla="val 25000"/>
+            </a:avLst>
+          </a:prstGeom>
+          <a:solidFill>
+            <a:srgbClr val="0F3460"/>
+          </a:solidFill>
+          <a:ln w="9525">
+            <a:solidFill>
+              <a:srgbClr val="00D2FF"/>
+            </a:solidFill>
+          </a:ln>
+          <a:effectLst/>
+        </p:spPr>
+        <p:style>
+          <a:lnRef idx="1">
+            <a:schemeClr val="accent1"/>
+          </a:lnRef>
+          <a:fillRef idx="3">
+            <a:schemeClr val="accent1"/>
+          </a:fillRef>
+          <a:effectRef idx="2">
+            <a:schemeClr val="accent1"/>
+          </a:effectRef>
+          <a:fontRef idx="minor">
+            <a:schemeClr val="lt1"/>
+          </a:fontRef>
+        </p:style>
+        <p:txBody>
+          <a:bodyPr rtlCol="0" anchor="ctr" lIns="0" rIns="0" tIns="0" bIns="0" wrap="square"/>
+          <a:lstStyle/>
+          <a:p>
+            <a:pPr algn="ctr"/>
+            <a:r>
+              <a:rPr sz="1100" b="0">
+                <a:solidFill>
+                  <a:srgbClr val="FFFFFF"/>
+                </a:solidFill>
+                <a:latin typeface="Calibri"/>
+              </a:rPr>
+              <a:t>PostgreSQL</a:t>
+            </a:r>
+          </a:p>
+          <a:p>
+            <a:pPr algn="ctr"/>
+            <a:r>
+              <a:rPr sz="1100" b="0">
+                <a:solidFill>
+                  <a:srgbClr val="FFFFFF"/>
+                </a:solidFill>
+                <a:latin typeface="Calibri"/>
+              </a:rPr>
+              <a:t>sessions / messages</a:t>
+            </a:r>
+          </a:p>
+        </p:txBody>
+      </p:sp>
+      <p:sp>
+        <p:nvSpPr>
+          <p:cNvPr id="20" name="Rounded Rectangle 19"/>
+          <p:cNvSpPr/>
+          <p:nvPr/>
+        </p:nvSpPr>
+        <p:spPr>
+          <a:xfrm>
+            <a:off x="6309360" y="5029200"/>
+            <a:ext cx="2377440" cy="640080"/>
+          </a:xfrm>
+          <a:prstGeom prst="roundRect">
+            <a:avLst>
+              <a:gd name="adj" fmla="val 25000"/>
+            </a:avLst>
+          </a:prstGeom>
+          <a:solidFill>
+            <a:srgbClr val="0F3460"/>
+          </a:solidFill>
+          <a:ln w="9525">
+            <a:solidFill>
+              <a:srgbClr val="00D2FF"/>
+            </a:solidFill>
+          </a:ln>
+          <a:effectLst/>
+        </p:spPr>
+        <p:style>
+          <a:lnRef idx="1">
+            <a:schemeClr val="accent1"/>
+          </a:lnRef>
+          <a:fillRef idx="3">
+            <a:schemeClr val="accent1"/>
+          </a:fillRef>
+          <a:effectRef idx="2">
+            <a:schemeClr val="accent1"/>
+          </a:effectRef>
+          <a:fontRef idx="minor">
+            <a:schemeClr val="lt1"/>
+          </a:fontRef>
+        </p:style>
+        <p:txBody>
+          <a:bodyPr rtlCol="0" anchor="ctr" lIns="0" rIns="0" tIns="0" bIns="0" wrap="square"/>
+          <a:lstStyle/>
+          <a:p>
+            <a:pPr algn="ctr"/>
+            <a:r>
+              <a:rPr sz="1100" b="0">
+                <a:solidFill>
+                  <a:srgbClr val="FFFFFF"/>
+                </a:solidFill>
+                <a:latin typeface="Calibri"/>
+              </a:rPr>
+              <a:t>Persistent Volume</a:t>
+            </a:r>
+          </a:p>
+          <a:p>
+            <a:pPr algn="ctr"/>
+            <a:r>
+              <a:rPr sz="1100" b="0">
+                <a:solidFill>
+                  <a:srgbClr val="FFFFFF"/>
+                </a:solidFill>
+                <a:latin typeface="Calibri"/>
+              </a:rPr>
+              <a:t>311 CSV · charts · reports</a:t>
+            </a:r>
+          </a:p>
+        </p:txBody>
+      </p:sp>
+      <p:sp>
+        <p:nvSpPr>
+          <p:cNvPr id="21" name="Rounded Rectangle 20"/>
+          <p:cNvSpPr/>
+          <p:nvPr/>
+        </p:nvSpPr>
+        <p:spPr>
+          <a:xfrm>
+            <a:off x="9235440" y="1737360"/>
+            <a:ext cx="2377440" cy="4206240"/>
+          </a:xfrm>
+          <a:prstGeom prst="roundRect">
+            <a:avLst>
+              <a:gd name="adj" fmla="val 4000"/>
+            </a:avLst>
+          </a:prstGeom>
+          <a:noFill/>
+          <a:ln w="15875">
+            <a:solidFill>
+              <a:srgbClr val="FFD93D"/>
+            </a:solidFill>
+            <a:prstDash val="lgDash"/>
+          </a:ln>
+          <a:effectLst/>
+        </p:spPr>
+        <p:style>
+          <a:lnRef idx="1">
+            <a:schemeClr val="accent1"/>
+          </a:lnRef>
+          <a:fillRef idx="3">
+            <a:schemeClr val="accent1"/>
+          </a:fillRef>
+          <a:effectRef idx="2">
+            <a:schemeClr val="accent1"/>
+          </a:effectRef>
+          <a:fontRef idx="minor">
+            <a:schemeClr val="lt1"/>
+          </a:fontRef>
+        </p:style>
+        <p:txBody>
+          <a:bodyPr rtlCol="0" anchor="ctr"/>
+          <a:lstStyle/>
+          <a:p>
+            <a:pPr algn="ctr"/>
+          </a:p>
+        </p:txBody>
+      </p:sp>
+      <p:sp>
+        <p:nvSpPr>
+          <p:cNvPr id="22" name="TextBox 21"/>
+          <p:cNvSpPr txBox="1"/>
+          <p:nvPr/>
+        </p:nvSpPr>
+        <p:spPr>
+          <a:xfrm>
+            <a:off x="9418320" y="1810512"/>
+            <a:ext cx="2377440" cy="320040"/>
+          </a:xfrm>
+          <a:prstGeom prst="rect">
+            <a:avLst/>
+          </a:prstGeom>
+          <a:noFill/>
+        </p:spPr>
+        <p:txBody>
+          <a:bodyPr wrap="square" lIns="0" rIns="0" tIns="0" bIns="0">
+            <a:spAutoFit/>
+          </a:bodyPr>
+          <a:lstStyle/>
+          <a:p>
+            <a:pPr algn="l"/>
+            <a:r>
+              <a:rPr sz="1200" b="1">
+                <a:solidFill>
+                  <a:srgbClr val="FFD93D"/>
+                </a:solidFill>
+                <a:latin typeface="Calibri"/>
+              </a:rPr>
+              <a:t>EXTERNAL</a:t>
+            </a:r>
+          </a:p>
+        </p:txBody>
+      </p:sp>
+      <p:sp>
+        <p:nvSpPr>
+          <p:cNvPr id="23" name="Rounded Rectangle 22"/>
+          <p:cNvSpPr/>
+          <p:nvPr/>
+        </p:nvSpPr>
+        <p:spPr>
+          <a:xfrm>
+            <a:off x="9418320" y="2560320"/>
+            <a:ext cx="2057400" cy="822960"/>
+          </a:xfrm>
+          <a:prstGeom prst="roundRect">
+            <a:avLst>
+              <a:gd name="adj" fmla="val 25000"/>
+            </a:avLst>
+          </a:prstGeom>
+          <a:solidFill>
+            <a:srgbClr val="16213E"/>
+          </a:solidFill>
+          <a:ln w="9525">
+            <a:solidFill>
+              <a:srgbClr val="00D2FF"/>
+            </a:solidFill>
+          </a:ln>
+          <a:effectLst/>
+        </p:spPr>
+        <p:style>
+          <a:lnRef idx="1">
+            <a:schemeClr val="accent1"/>
+          </a:lnRef>
+          <a:fillRef idx="3">
+            <a:schemeClr val="accent1"/>
+          </a:fillRef>
+          <a:effectRef idx="2">
+            <a:schemeClr val="accent1"/>
+          </a:effectRef>
+          <a:fontRef idx="minor">
+            <a:schemeClr val="lt1"/>
+          </a:fontRef>
+        </p:style>
+        <p:txBody>
+          <a:bodyPr rtlCol="0" anchor="ctr" lIns="0" rIns="0" tIns="0" bIns="0" wrap="square"/>
+          <a:lstStyle/>
+          <a:p>
+            <a:pPr algn="ctr"/>
+            <a:r>
+              <a:rPr sz="1200" b="1">
+                <a:solidFill>
+                  <a:srgbClr val="FFFFFF"/>
+                </a:solidFill>
+                <a:latin typeface="Calibri"/>
+              </a:rPr>
+              <a:t>Anthropic API</a:t>
+            </a:r>
+          </a:p>
+          <a:p>
+            <a:pPr algn="ctr"/>
+            <a:r>
+              <a:rPr sz="1200" b="1">
+                <a:solidFill>
+                  <a:srgbClr val="FFFFFF"/>
+                </a:solidFill>
+                <a:latin typeface="Calibri"/>
+              </a:rPr>
+              <a:t>Claude models</a:t>
+            </a:r>
+          </a:p>
+        </p:txBody>
+      </p:sp>
+      <p:sp>
+        <p:nvSpPr>
+          <p:cNvPr id="24" name="Rounded Rectangle 23"/>
+          <p:cNvSpPr/>
+          <p:nvPr/>
+        </p:nvSpPr>
+        <p:spPr>
+          <a:xfrm>
+            <a:off x="9418320" y="3749039"/>
+            <a:ext cx="2057400" cy="822960"/>
+          </a:xfrm>
+          <a:prstGeom prst="roundRect">
+            <a:avLst>
+              <a:gd name="adj" fmla="val 25000"/>
+            </a:avLst>
+          </a:prstGeom>
+          <a:solidFill>
+            <a:srgbClr val="16213E"/>
+          </a:solidFill>
+          <a:ln w="9525">
+            <a:solidFill>
+              <a:srgbClr val="00D2FF"/>
+            </a:solidFill>
+          </a:ln>
+          <a:effectLst/>
+        </p:spPr>
+        <p:style>
+          <a:lnRef idx="1">
+            <a:schemeClr val="accent1"/>
+          </a:lnRef>
+          <a:fillRef idx="3">
+            <a:schemeClr val="accent1"/>
+          </a:fillRef>
+          <a:effectRef idx="2">
+            <a:schemeClr val="accent1"/>
+          </a:effectRef>
+          <a:fontRef idx="minor">
+            <a:schemeClr val="lt1"/>
+          </a:fontRef>
+        </p:style>
+        <p:txBody>
+          <a:bodyPr rtlCol="0" anchor="ctr" lIns="0" rIns="0" tIns="0" bIns="0" wrap="square"/>
+          <a:lstStyle/>
+          <a:p>
+            <a:pPr algn="ctr"/>
+            <a:r>
+              <a:rPr sz="1200" b="1">
+                <a:solidFill>
+                  <a:srgbClr val="FFFFFF"/>
+                </a:solidFill>
+                <a:latin typeface="Calibri"/>
+              </a:rPr>
+              <a:t>Socrata</a:t>
+            </a:r>
+          </a:p>
+          <a:p>
+            <a:pPr algn="ctr"/>
+            <a:r>
+              <a:rPr sz="1200" b="1">
+                <a:solidFill>
+                  <a:srgbClr val="FFFFFF"/>
+                </a:solidFill>
+                <a:latin typeface="Calibri"/>
+              </a:rPr>
+              <a:t>xwdj-i9he dataset</a:t>
+            </a:r>
+          </a:p>
+        </p:txBody>
+      </p:sp>
+      <p:cxnSp>
+        <p:nvCxnSpPr>
+          <p:cNvPr id="25" name="Connector 24"/>
+          <p:cNvCxnSpPr/>
+          <p:nvPr/>
+        </p:nvCxnSpPr>
+        <p:spPr>
+          <a:xfrm flipV="1">
+            <a:off x="2697480" y="2926080"/>
+            <a:ext cx="822960" cy="822959"/>
+          </a:xfrm>
+          <a:prstGeom prst="bentConnector3">
+            <a:avLst/>
+          </a:prstGeom>
+          <a:ln w="19050">
+            <a:solidFill>
+              <a:srgbClr val="00D2FF"/>
+            </a:solidFill>
+          </a:ln>
+        </p:spPr>
+        <p:style>
+          <a:lnRef idx="2">
+            <a:schemeClr val="accent1"/>
+          </a:lnRef>
+          <a:fillRef idx="0">
+            <a:schemeClr val="accent1"/>
+          </a:fillRef>
+          <a:effectRef idx="1">
+            <a:schemeClr val="accent1"/>
+          </a:effectRef>
+          <a:fontRef idx="minor">
+            <a:schemeClr val="tx1"/>
+          </a:fontRef>
+        </p:style>
+      </p:cxnSp>
+      <p:cxnSp>
+        <p:nvCxnSpPr>
+          <p:cNvPr id="26" name="Connector 25"/>
+          <p:cNvCxnSpPr/>
+          <p:nvPr/>
+        </p:nvCxnSpPr>
+        <p:spPr>
+          <a:xfrm>
+            <a:off x="5897880" y="2880360"/>
+            <a:ext cx="411480" cy="0"/>
+          </a:xfrm>
+          <a:prstGeom prst="bentConnector3">
+            <a:avLst/>
+          </a:prstGeom>
+          <a:ln w="19050">
+            <a:solidFill>
+              <a:srgbClr val="00D2FF"/>
+            </a:solidFill>
+          </a:ln>
+        </p:spPr>
+        <p:style>
+          <a:lnRef idx="2">
+            <a:schemeClr val="accent1"/>
+          </a:lnRef>
+          <a:fillRef idx="0">
+            <a:schemeClr val="accent1"/>
+          </a:fillRef>
+          <a:effectRef idx="1">
+            <a:schemeClr val="accent1"/>
+          </a:effectRef>
+          <a:fontRef idx="minor">
+            <a:schemeClr val="tx1"/>
+          </a:fontRef>
+        </p:style>
+      </p:cxnSp>
+      <p:cxnSp>
+        <p:nvCxnSpPr>
+          <p:cNvPr id="27" name="Connector 26"/>
+          <p:cNvCxnSpPr/>
+          <p:nvPr/>
+        </p:nvCxnSpPr>
+        <p:spPr>
+          <a:xfrm>
+            <a:off x="7498079" y="4434840"/>
+            <a:ext cx="0" cy="594360"/>
+          </a:xfrm>
+          <a:prstGeom prst="bentConnector3">
+            <a:avLst/>
+          </a:prstGeom>
+          <a:ln w="19050">
+            <a:solidFill>
+              <a:srgbClr val="7B2FF7"/>
+            </a:solidFill>
+          </a:ln>
+        </p:spPr>
+        <p:style>
+          <a:lnRef idx="2">
+            <a:schemeClr val="accent1"/>
+          </a:lnRef>
+          <a:fillRef idx="0">
+            <a:schemeClr val="accent1"/>
+          </a:fillRef>
+          <a:effectRef idx="1">
+            <a:schemeClr val="accent1"/>
+          </a:effectRef>
+          <a:fontRef idx="minor">
+            <a:schemeClr val="tx1"/>
+          </a:fontRef>
+        </p:style>
+      </p:cxnSp>
+      <p:cxnSp>
+        <p:nvCxnSpPr>
+          <p:cNvPr id="28" name="Connector 27"/>
+          <p:cNvCxnSpPr/>
+          <p:nvPr/>
+        </p:nvCxnSpPr>
+        <p:spPr>
+          <a:xfrm>
+            <a:off x="4709160" y="3246120"/>
+            <a:ext cx="0" cy="1783080"/>
+          </a:xfrm>
+          <a:prstGeom prst="bentConnector3">
+            <a:avLst/>
+          </a:prstGeom>
+          <a:ln w="19050">
+            <a:solidFill>
+              <a:srgbClr val="7B2FF7"/>
+            </a:solidFill>
+          </a:ln>
+        </p:spPr>
+        <p:style>
+          <a:lnRef idx="2">
+            <a:schemeClr val="accent1"/>
+          </a:lnRef>
+          <a:fillRef idx="0">
+            <a:schemeClr val="accent1"/>
+          </a:fillRef>
+          <a:effectRef idx="1">
+            <a:schemeClr val="accent1"/>
+          </a:effectRef>
+          <a:fontRef idx="minor">
+            <a:schemeClr val="tx1"/>
+          </a:fontRef>
+        </p:style>
+      </p:cxnSp>
+      <p:cxnSp>
+        <p:nvCxnSpPr>
+          <p:cNvPr id="29" name="Connector 28"/>
+          <p:cNvCxnSpPr/>
+          <p:nvPr/>
+        </p:nvCxnSpPr>
+        <p:spPr>
+          <a:xfrm flipV="1">
+            <a:off x="8686800" y="2971800"/>
+            <a:ext cx="731520" cy="548640"/>
+          </a:xfrm>
+          <a:prstGeom prst="bentConnector3">
+            <a:avLst/>
+          </a:prstGeom>
+          <a:ln w="19050">
+            <a:solidFill>
+              <a:srgbClr val="FFD93D"/>
+            </a:solidFill>
+          </a:ln>
+        </p:spPr>
+        <p:style>
+          <a:lnRef idx="2">
+            <a:schemeClr val="accent1"/>
+          </a:lnRef>
+          <a:fillRef idx="0">
+            <a:schemeClr val="accent1"/>
+          </a:fillRef>
+          <a:effectRef idx="1">
+            <a:schemeClr val="accent1"/>
+          </a:effectRef>
+          <a:fontRef idx="minor">
+            <a:schemeClr val="tx1"/>
+          </a:fontRef>
+        </p:style>
+      </p:cxnSp>
+      <p:cxnSp>
+        <p:nvCxnSpPr>
+          <p:cNvPr id="30" name="Connector 29"/>
+          <p:cNvCxnSpPr/>
+          <p:nvPr/>
+        </p:nvCxnSpPr>
+        <p:spPr>
+          <a:xfrm>
+            <a:off x="8686800" y="4160520"/>
+            <a:ext cx="731520" cy="0"/>
+          </a:xfrm>
+          <a:prstGeom prst="bentConnector3">
+            <a:avLst/>
+          </a:prstGeom>
+          <a:ln w="19050">
+            <a:solidFill>
+              <a:srgbClr val="FFD93D"/>
+            </a:solidFill>
+          </a:ln>
+        </p:spPr>
+        <p:style>
+          <a:lnRef idx="2">
+            <a:schemeClr val="accent1"/>
+          </a:lnRef>
+          <a:fillRef idx="0">
+            <a:schemeClr val="accent1"/>
+          </a:fillRef>
+          <a:effectRef idx="1">
+            <a:schemeClr val="accent1"/>
+          </a:effectRef>
+          <a:fontRef idx="minor">
+            <a:schemeClr val="tx1"/>
+          </a:fontRef>
+        </p:style>
+      </p:cxnSp>
+      <p:sp>
+        <p:nvSpPr>
+          <p:cNvPr id="31" name="TextBox 30"/>
+          <p:cNvSpPr txBox="1"/>
+          <p:nvPr/>
+        </p:nvSpPr>
+        <p:spPr>
+          <a:xfrm>
+            <a:off x="548640" y="6080760"/>
+            <a:ext cx="10972800" cy="320040"/>
+          </a:xfrm>
+          <a:prstGeom prst="rect">
+            <a:avLst/>
+          </a:prstGeom>
+          <a:noFill/>
+        </p:spPr>
+        <p:txBody>
+          <a:bodyPr wrap="square" lIns="0" rIns="0" tIns="0" bIns="0">
+            <a:spAutoFit/>
+          </a:bodyPr>
+          <a:lstStyle/>
+          <a:p>
+            <a:pPr algn="ctr"/>
+            <a:r>
+              <a:rPr sz="1200" b="0">
+                <a:solidFill>
+                  <a:srgbClr val="9999AA"/>
+                </a:solidFill>
+                <a:latin typeface="Calibri"/>
+              </a:rPr>
+              <a:t>SSE streaming · Vercel AI SDK v6 protocol · JWT auth · delta-merge on startup</a:t>
+            </a:r>
+          </a:p>
+        </p:txBody>
+      </p:sp>
+      <p:sp>
+        <p:nvSpPr>
+          <p:cNvPr id="32" name="TextBox 31"/>
+          <p:cNvSpPr txBox="1"/>
+          <p:nvPr/>
+        </p:nvSpPr>
+        <p:spPr>
+          <a:xfrm>
+            <a:off x="548640" y="6446520"/>
+            <a:ext cx="3657600" cy="274320"/>
+          </a:xfrm>
+          <a:prstGeom prst="rect">
+            <a:avLst/>
+          </a:prstGeom>
+          <a:noFill/>
+        </p:spPr>
+        <p:txBody>
+          <a:bodyPr wrap="square" lIns="0" rIns="0" tIns="0" bIns="0">
+            <a:spAutoFit/>
+          </a:bodyPr>
+          <a:lstStyle/>
+          <a:p>
+            <a:pPr algn="l"/>
+            <a:r>
+              <a:rPr sz="1000" b="0">
+                <a:solidFill>
+                  <a:srgbClr val="9999AA"/>
+                </a:solidFill>
+                <a:latin typeface="Calibri"/>
+              </a:rPr>
+              <a:t>Agent Austin</a:t>
+            </a:r>
+          </a:p>
+        </p:txBody>
+      </p:sp>
+      <p:sp>
+        <p:nvSpPr>
+          <p:cNvPr id="33" name="TextBox 32"/>
+          <p:cNvSpPr txBox="1"/>
+          <p:nvPr/>
+        </p:nvSpPr>
+        <p:spPr>
+          <a:xfrm>
+            <a:off x="10972800" y="6446520"/>
+            <a:ext cx="731520" cy="274320"/>
+          </a:xfrm>
+          <a:prstGeom prst="rect">
+            <a:avLst/>
+          </a:prstGeom>
+          <a:noFill/>
+        </p:spPr>
+        <p:txBody>
+          <a:bodyPr wrap="square" lIns="0" rIns="0" tIns="0" bIns="0">
+            <a:spAutoFit/>
+          </a:bodyPr>
+          <a:lstStyle/>
+          <a:p>
+            <a:pPr algn="r"/>
+            <a:r>
+              <a:rPr sz="1000" b="0">
+                <a:solidFill>
+                  <a:srgbClr val="9999AA"/>
+                </a:solidFill>
+                <a:latin typeface="Calibri"/>
+              </a:rPr>
+              <a:t>4 / 6</a:t>
+            </a:r>
+          </a:p>
+        </p:txBody>
+      </p:sp>
+    </p:spTree>
+  </p:cSld>
+  <p:clrMapOvr>
+    <a:masterClrMapping/>
+  </p:clrMapOvr>
+</p:sld>
+</file>
+
+<file path=ppt/slides/slide5.xml><?xml version="1.0" encoding="utf-8"?>
+<p:sld xmlns:a="http://schemas.openxmlformats.org/drawingml/2006/main" xmlns:p="http://schemas.openxmlformats.org/presentationml/2006/main" xmlns:r="http://schemas.openxmlformats.org/officeDocument/2006/relationships">
+  <p:cSld>
+    <p:spTree>
+      <p:nvGrpSpPr>
+        <p:cNvPr id="1" name=""/>
+        <p:cNvGrpSpPr/>
+        <p:nvPr/>
+      </p:nvGrpSpPr>
+      <p:grpSpPr/>
+      <p:sp>
+        <p:nvSpPr>
+          <p:cNvPr id="2" name="Rectangle 1"/>
+          <p:cNvSpPr/>
+          <p:nvPr/>
+        </p:nvSpPr>
+        <p:spPr>
+          <a:xfrm>
+            <a:off x="0" y="0"/>
+            <a:ext cx="12191695" cy="6858000"/>
+          </a:xfrm>
+          <a:prstGeom prst="rect">
+            <a:avLst/>
+          </a:prstGeom>
+          <a:solidFill>
+            <a:srgbClr val="1A1A2E"/>
+          </a:solidFill>
+          <a:ln>
+            <a:noFill/>
+          </a:ln>
+          <a:effectLst/>
+        </p:spPr>
+        <p:style>
+          <a:lnRef idx="1">
+            <a:schemeClr val="accent1"/>
+          </a:lnRef>
+          <a:fillRef idx="3">
+            <a:schemeClr val="accent1"/>
+          </a:fillRef>
+          <a:effectRef idx="2">
+            <a:schemeClr val="accent1"/>
+          </a:effectRef>
+          <a:fontRef idx="minor">
+            <a:schemeClr val="lt1"/>
+          </a:fontRef>
+        </p:style>
+        <p:txBody>
+          <a:bodyPr rtlCol="0" anchor="ctr"/>
+          <a:lstStyle/>
+          <a:p>
+            <a:pPr algn="ctr"/>
+          </a:p>
+        </p:txBody>
+      </p:sp>
+      <p:sp>
+        <p:nvSpPr>
+          <p:cNvPr id="3" name="Rectangle 2"/>
+          <p:cNvSpPr/>
+          <p:nvPr/>
+        </p:nvSpPr>
+        <p:spPr>
+          <a:xfrm>
+            <a:off x="548640" y="548640"/>
+            <a:ext cx="109728" cy="457200"/>
+          </a:xfrm>
+          <a:prstGeom prst="rect">
+            <a:avLst/>
+          </a:prstGeom>
+          <a:solidFill>
+            <a:srgbClr val="7B2FF7"/>
+          </a:solidFill>
+          <a:ln>
+            <a:noFill/>
+          </a:ln>
+        </p:spPr>
+        <p:style>
+          <a:lnRef idx="1">
+            <a:schemeClr val="accent1"/>
+          </a:lnRef>
+          <a:fillRef idx="3">
+            <a:schemeClr val="accent1"/>
+          </a:fillRef>
+          <a:effectRef idx="2">
+            <a:schemeClr val="accent1"/>
+          </a:effectRef>
+          <a:fontRef idx="minor">
+            <a:schemeClr val="lt1"/>
+          </a:fontRef>
+        </p:style>
+        <p:txBody>
+          <a:bodyPr rtlCol="0" anchor="ctr"/>
+          <a:lstStyle/>
+          <a:p>
+            <a:pPr algn="ctr"/>
+          </a:p>
+        </p:txBody>
+      </p:sp>
+      <p:sp>
+        <p:nvSpPr>
+          <p:cNvPr id="4" name="TextBox 3"/>
+          <p:cNvSpPr txBox="1"/>
+          <p:nvPr/>
+        </p:nvSpPr>
+        <p:spPr>
+          <a:xfrm>
+            <a:off x="777240" y="502920"/>
+            <a:ext cx="10972800" cy="640080"/>
+          </a:xfrm>
+          <a:prstGeom prst="rect">
+            <a:avLst/>
+          </a:prstGeom>
+          <a:noFill/>
+        </p:spPr>
+        <p:txBody>
+          <a:bodyPr wrap="square" lIns="0" rIns="0" tIns="0" bIns="0">
+            <a:spAutoFit/>
+          </a:bodyPr>
+          <a:lstStyle/>
+          <a:p>
+            <a:pPr algn="l"/>
+            <a:r>
+              <a:rPr sz="3600" b="1">
+                <a:solidFill>
+                  <a:srgbClr val="FFFFFF"/>
+                </a:solidFill>
+                <a:latin typeface="Calibri"/>
+              </a:rPr>
+              <a:t>Agent Skills</a:t>
+            </a:r>
+          </a:p>
+        </p:txBody>
+      </p:sp>
+      <p:sp>
+        <p:nvSpPr>
+          <p:cNvPr id="5" name="TextBox 4"/>
+          <p:cNvSpPr txBox="1"/>
+          <p:nvPr/>
+        </p:nvSpPr>
+        <p:spPr>
+          <a:xfrm>
+            <a:off x="777240" y="1097280"/>
+            <a:ext cx="10972800" cy="365760"/>
+          </a:xfrm>
+          <a:prstGeom prst="rect">
+            <a:avLst/>
+          </a:prstGeom>
+          <a:noFill/>
+        </p:spPr>
+        <p:txBody>
+          <a:bodyPr wrap="square" lIns="0" rIns="0" tIns="0" bIns="0">
+            <a:spAutoFit/>
+          </a:bodyPr>
+          <a:lstStyle/>
+          <a:p>
+            <a:pPr algn="l"/>
+            <a:r>
+              <a:rPr sz="1400" b="0">
+                <a:solidFill>
+                  <a:srgbClr val="9999AA"/>
+                </a:solidFill>
+                <a:latin typeface="Calibri"/>
+              </a:rPr>
+              <a:t>Markdown instructions under agent311/.claude/skills/ — the SDK picks them up automatically.</a:t>
+            </a:r>
+          </a:p>
+        </p:txBody>
+      </p:sp>
+      <p:sp>
+        <p:nvSpPr>
+          <p:cNvPr id="6" name="Rounded Rectangle 5"/>
+          <p:cNvSpPr/>
+          <p:nvPr/>
+        </p:nvSpPr>
+        <p:spPr>
+          <a:xfrm>
+            <a:off x="777240" y="1645920"/>
+            <a:ext cx="3657600" cy="2240280"/>
+          </a:xfrm>
+          <a:prstGeom prst="roundRect">
+            <a:avLst>
+              <a:gd name="adj" fmla="val 8000"/>
+            </a:avLst>
+          </a:prstGeom>
+          <a:solidFill>
+            <a:srgbClr val="16213E"/>
+          </a:solidFill>
+          <a:ln>
+            <a:noFill/>
+          </a:ln>
+          <a:effectLst/>
+        </p:spPr>
+        <p:style>
+          <a:lnRef idx="1">
+            <a:schemeClr val="accent1"/>
+          </a:lnRef>
+          <a:fillRef idx="3">
+            <a:schemeClr val="accent1"/>
+          </a:fillRef>
+          <a:effectRef idx="2">
+            <a:schemeClr val="accent1"/>
+          </a:effectRef>
+          <a:fontRef idx="minor">
+            <a:schemeClr val="lt1"/>
+          </a:fontRef>
+        </p:style>
+        <p:txBody>
+          <a:bodyPr rtlCol="0" anchor="ctr"/>
+          <a:lstStyle/>
+          <a:p>
+            <a:pPr algn="ctr"/>
+          </a:p>
+        </p:txBody>
+      </p:sp>
+      <p:sp>
+        <p:nvSpPr>
+          <p:cNvPr id="7" name="Rectangle 6"/>
+          <p:cNvSpPr/>
+          <p:nvPr/>
+        </p:nvSpPr>
+        <p:spPr>
+          <a:xfrm>
+            <a:off x="777240" y="1645920"/>
+            <a:ext cx="3657600" cy="109728"/>
+          </a:xfrm>
+          <a:prstGeom prst="rect">
+            <a:avLst/>
+          </a:prstGeom>
+          <a:solidFill>
+            <a:srgbClr val="00D2FF"/>
+          </a:solidFill>
+          <a:ln>
+            <a:noFill/>
+          </a:ln>
+        </p:spPr>
+        <p:style>
+          <a:lnRef idx="1">
+            <a:schemeClr val="accent1"/>
+          </a:lnRef>
+          <a:fillRef idx="3">
+            <a:schemeClr val="accent1"/>
+          </a:fillRef>
+          <a:effectRef idx="2">
+            <a:schemeClr val="accent1"/>
+          </a:effectRef>
+          <a:fontRef idx="minor">
+            <a:schemeClr val="lt1"/>
+          </a:fontRef>
+        </p:style>
+        <p:txBody>
+          <a:bodyPr rtlCol="0" anchor="ctr"/>
+          <a:lstStyle/>
+          <a:p>
+            <a:pPr algn="ctr"/>
+          </a:p>
+        </p:txBody>
+      </p:sp>
+      <p:sp>
+        <p:nvSpPr>
+          <p:cNvPr id="8" name="TextBox 7"/>
+          <p:cNvSpPr txBox="1"/>
+          <p:nvPr/>
+        </p:nvSpPr>
+        <p:spPr>
+          <a:xfrm>
+            <a:off x="1005840" y="1920240"/>
+            <a:ext cx="3200400" cy="457200"/>
+          </a:xfrm>
+          <a:prstGeom prst="rect">
+            <a:avLst/>
+          </a:prstGeom>
+          <a:noFill/>
+        </p:spPr>
+        <p:txBody>
+          <a:bodyPr wrap="square" lIns="0" rIns="0" tIns="0" bIns="0">
+            <a:spAutoFit/>
+          </a:bodyPr>
+          <a:lstStyle/>
+          <a:p>
+            <a:pPr algn="l"/>
+            <a:r>
+              <a:rPr sz="1800" b="1">
+                <a:solidFill>
+                  <a:srgbClr val="FFFFFF"/>
+                </a:solidFill>
+                <a:latin typeface="Consolas"/>
+              </a:rPr>
+              <a:t>download-311-data</a:t>
+            </a:r>
+          </a:p>
+        </p:txBody>
+      </p:sp>
+      <p:sp>
+        <p:nvSpPr>
+          <p:cNvPr id="9" name="TextBox 8"/>
+          <p:cNvSpPr txBox="1"/>
+          <p:nvPr/>
+        </p:nvSpPr>
+        <p:spPr>
+          <a:xfrm>
+            <a:off x="1005840" y="2514600"/>
+            <a:ext cx="3200400" cy="1188720"/>
+          </a:xfrm>
+          <a:prstGeom prst="rect">
+            <a:avLst/>
+          </a:prstGeom>
+          <a:noFill/>
+        </p:spPr>
+        <p:txBody>
+          <a:bodyPr wrap="square" lIns="0" rIns="0" tIns="0" bIns="0">
+            <a:spAutoFit/>
+          </a:bodyPr>
+          <a:lstStyle/>
+          <a:p>
+            <a:pPr algn="l"/>
+            <a:r>
+              <a:rPr sz="1400" b="0">
+                <a:solidFill>
+                  <a:srgbClr val="E0E0E0"/>
+                </a:solidFill>
+                <a:latin typeface="Calibri"/>
+              </a:rPr>
+              <a:t>Pulls Socrata CSV</a:t>
+            </a:r>
+          </a:p>
+          <a:p>
+            <a:pPr algn="l"/>
+            <a:r>
+              <a:rPr sz="1400" b="0">
+                <a:solidFill>
+                  <a:srgbClr val="E0E0E0"/>
+                </a:solidFill>
+                <a:latin typeface="Calibri"/>
+              </a:rPr>
+              <a:t>pagination + delta merge</a:t>
+            </a:r>
+          </a:p>
+        </p:txBody>
+      </p:sp>
+      <p:sp>
+        <p:nvSpPr>
+          <p:cNvPr id="10" name="Rounded Rectangle 9"/>
+          <p:cNvSpPr/>
+          <p:nvPr/>
+        </p:nvSpPr>
+        <p:spPr>
+          <a:xfrm>
+            <a:off x="4663440" y="1645920"/>
+            <a:ext cx="3657600" cy="2240280"/>
+          </a:xfrm>
+          <a:prstGeom prst="roundRect">
+            <a:avLst>
+              <a:gd name="adj" fmla="val 8000"/>
+            </a:avLst>
+          </a:prstGeom>
+          <a:solidFill>
+            <a:srgbClr val="16213E"/>
+          </a:solidFill>
+          <a:ln>
+            <a:noFill/>
+          </a:ln>
+          <a:effectLst/>
+        </p:spPr>
+        <p:style>
+          <a:lnRef idx="1">
+            <a:schemeClr val="accent1"/>
+          </a:lnRef>
+          <a:fillRef idx="3">
+            <a:schemeClr val="accent1"/>
+          </a:fillRef>
+          <a:effectRef idx="2">
+            <a:schemeClr val="accent1"/>
+          </a:effectRef>
+          <a:fontRef idx="minor">
+            <a:schemeClr val="lt1"/>
+          </a:fontRef>
+        </p:style>
+        <p:txBody>
+          <a:bodyPr rtlCol="0" anchor="ctr"/>
+          <a:lstStyle/>
+          <a:p>
+            <a:pPr algn="ctr"/>
+          </a:p>
+        </p:txBody>
+      </p:sp>
+      <p:sp>
+        <p:nvSpPr>
+          <p:cNvPr id="11" name="Rectangle 10"/>
+          <p:cNvSpPr/>
+          <p:nvPr/>
+        </p:nvSpPr>
+        <p:spPr>
+          <a:xfrm>
+            <a:off x="4663440" y="1645920"/>
+            <a:ext cx="3657600" cy="109728"/>
+          </a:xfrm>
+          <a:prstGeom prst="rect">
+            <a:avLst/>
+          </a:prstGeom>
+          <a:solidFill>
+            <a:srgbClr val="7B2FF7"/>
+          </a:solidFill>
+          <a:ln>
+            <a:noFill/>
+          </a:ln>
+        </p:spPr>
+        <p:style>
+          <a:lnRef idx="1">
+            <a:schemeClr val="accent1"/>
+          </a:lnRef>
+          <a:fillRef idx="3">
+            <a:schemeClr val="accent1"/>
+          </a:fillRef>
+          <a:effectRef idx="2">
+            <a:schemeClr val="accent1"/>
+          </a:effectRef>
+          <a:fontRef idx="minor">
+            <a:schemeClr val="lt1"/>
+          </a:fontRef>
+        </p:style>
+        <p:txBody>
+          <a:bodyPr rtlCol="0" anchor="ctr"/>
+          <a:lstStyle/>
+          <a:p>
+            <a:pPr algn="ctr"/>
+          </a:p>
+        </p:txBody>
+      </p:sp>
+      <p:sp>
+        <p:nvSpPr>
+          <p:cNvPr id="12" name="TextBox 11"/>
+          <p:cNvSpPr txBox="1"/>
+          <p:nvPr/>
+        </p:nvSpPr>
+        <p:spPr>
+          <a:xfrm>
+            <a:off x="4892040" y="1920240"/>
+            <a:ext cx="3200400" cy="457200"/>
+          </a:xfrm>
+          <a:prstGeom prst="rect">
+            <a:avLst/>
+          </a:prstGeom>
+          <a:noFill/>
+        </p:spPr>
+        <p:txBody>
+          <a:bodyPr wrap="square" lIns="0" rIns="0" tIns="0" bIns="0">
+            <a:spAutoFit/>
+          </a:bodyPr>
+          <a:lstStyle/>
+          <a:p>
+            <a:pPr algn="l"/>
+            <a:r>
+              <a:rPr sz="1800" b="1">
+                <a:solidFill>
+                  <a:srgbClr val="FFFFFF"/>
+                </a:solidFill>
+                <a:latin typeface="Consolas"/>
+              </a:rPr>
+              <a:t>analyze-311-data</a:t>
+            </a:r>
+          </a:p>
+        </p:txBody>
+      </p:sp>
+      <p:sp>
+        <p:nvSpPr>
+          <p:cNvPr id="13" name="TextBox 12"/>
+          <p:cNvSpPr txBox="1"/>
+          <p:nvPr/>
+        </p:nvSpPr>
+        <p:spPr>
+          <a:xfrm>
+            <a:off x="4892040" y="2514600"/>
+            <a:ext cx="3200400" cy="1188720"/>
+          </a:xfrm>
+          <a:prstGeom prst="rect">
+            <a:avLst/>
+          </a:prstGeom>
+          <a:noFill/>
+        </p:spPr>
+        <p:txBody>
+          <a:bodyPr wrap="square" lIns="0" rIns="0" tIns="0" bIns="0">
+            <a:spAutoFit/>
+          </a:bodyPr>
+          <a:lstStyle/>
+          <a:p>
+            <a:pPr algn="l"/>
+            <a:r>
+              <a:rPr sz="1400" b="0">
+                <a:solidFill>
+                  <a:srgbClr val="E0E0E0"/>
+                </a:solidFill>
+                <a:latin typeface="Calibri"/>
+              </a:rPr>
+              <a:t>Exploratory stats:</a:t>
+            </a:r>
+          </a:p>
+          <a:p>
+            <a:pPr algn="l"/>
+            <a:r>
+              <a:rPr sz="1400" b="0">
+                <a:solidFill>
+                  <a:srgbClr val="E0E0E0"/>
+                </a:solidFill>
+                <a:latin typeface="Calibri"/>
+              </a:rPr>
+              <a:t>types · timing · geography</a:t>
+            </a:r>
+          </a:p>
+        </p:txBody>
+      </p:sp>
+      <p:sp>
+        <p:nvSpPr>
+          <p:cNvPr id="14" name="Rounded Rectangle 13"/>
+          <p:cNvSpPr/>
+          <p:nvPr/>
+        </p:nvSpPr>
+        <p:spPr>
+          <a:xfrm>
+            <a:off x="8549640" y="1645920"/>
+            <a:ext cx="3657600" cy="2240280"/>
+          </a:xfrm>
+          <a:prstGeom prst="roundRect">
+            <a:avLst>
+              <a:gd name="adj" fmla="val 8000"/>
+            </a:avLst>
+          </a:prstGeom>
+          <a:solidFill>
+            <a:srgbClr val="16213E"/>
+          </a:solidFill>
+          <a:ln>
+            <a:noFill/>
+          </a:ln>
+          <a:effectLst/>
+        </p:spPr>
+        <p:style>
+          <a:lnRef idx="1">
+            <a:schemeClr val="accent1"/>
+          </a:lnRef>
+          <a:fillRef idx="3">
+            <a:schemeClr val="accent1"/>
+          </a:fillRef>
+          <a:effectRef idx="2">
+            <a:schemeClr val="accent1"/>
+          </a:effectRef>
+          <a:fontRef idx="minor">
+            <a:schemeClr val="lt1"/>
+          </a:fontRef>
+        </p:style>
+        <p:txBody>
+          <a:bodyPr rtlCol="0" anchor="ctr"/>
+          <a:lstStyle/>
+          <a:p>
+            <a:pPr algn="ctr"/>
+          </a:p>
+        </p:txBody>
+      </p:sp>
+      <p:sp>
+        <p:nvSpPr>
+          <p:cNvPr id="15" name="Rectangle 14"/>
+          <p:cNvSpPr/>
+          <p:nvPr/>
+        </p:nvSpPr>
+        <p:spPr>
+          <a:xfrm>
+            <a:off x="8549640" y="1645920"/>
+            <a:ext cx="3657600" cy="109728"/>
+          </a:xfrm>
+          <a:prstGeom prst="rect">
+            <a:avLst/>
+          </a:prstGeom>
+          <a:solidFill>
+            <a:srgbClr val="FF6B6B"/>
+          </a:solidFill>
+          <a:ln>
+            <a:noFill/>
+          </a:ln>
+        </p:spPr>
+        <p:style>
+          <a:lnRef idx="1">
+            <a:schemeClr val="accent1"/>
+          </a:lnRef>
+          <a:fillRef idx="3">
+            <a:schemeClr val="accent1"/>
+          </a:fillRef>
+          <a:effectRef idx="2">
+            <a:schemeClr val="accent1"/>
+          </a:effectRef>
+          <a:fontRef idx="minor">
+            <a:schemeClr val="lt1"/>
+          </a:fontRef>
+        </p:style>
+        <p:txBody>
+          <a:bodyPr rtlCol="0" anchor="ctr"/>
+          <a:lstStyle/>
+          <a:p>
+            <a:pPr algn="ctr"/>
+          </a:p>
+        </p:txBody>
+      </p:sp>
+      <p:sp>
+        <p:nvSpPr>
+          <p:cNvPr id="16" name="TextBox 15"/>
+          <p:cNvSpPr txBox="1"/>
+          <p:nvPr/>
+        </p:nvSpPr>
+        <p:spPr>
+          <a:xfrm>
+            <a:off x="8778240" y="1920240"/>
+            <a:ext cx="3200400" cy="457200"/>
+          </a:xfrm>
+          <a:prstGeom prst="rect">
+            <a:avLst/>
+          </a:prstGeom>
+          <a:noFill/>
+        </p:spPr>
+        <p:txBody>
+          <a:bodyPr wrap="square" lIns="0" rIns="0" tIns="0" bIns="0">
+            <a:spAutoFit/>
+          </a:bodyPr>
+          <a:lstStyle/>
+          <a:p>
+            <a:pPr algn="l"/>
+            <a:r>
+              <a:rPr sz="1800" b="1">
+                <a:solidFill>
+                  <a:srgbClr val="FFFFFF"/>
+                </a:solidFill>
+                <a:latin typeface="Consolas"/>
+              </a:rPr>
+              <a:t>visualize</a:t>
+            </a:r>
+          </a:p>
+        </p:txBody>
+      </p:sp>
+      <p:sp>
+        <p:nvSpPr>
+          <p:cNvPr id="17" name="TextBox 16"/>
+          <p:cNvSpPr txBox="1"/>
+          <p:nvPr/>
+        </p:nvSpPr>
+        <p:spPr>
+          <a:xfrm>
+            <a:off x="8778240" y="2514600"/>
+            <a:ext cx="3200400" cy="1188720"/>
+          </a:xfrm>
+          <a:prstGeom prst="rect">
+            <a:avLst/>
+          </a:prstGeom>
+          <a:noFill/>
+        </p:spPr>
+        <p:txBody>
+          <a:bodyPr wrap="square" lIns="0" rIns="0" tIns="0" bIns="0">
+            <a:spAutoFit/>
+          </a:bodyPr>
+          <a:lstStyle/>
+          <a:p>
+            <a:pPr algn="l"/>
+            <a:r>
+              <a:rPr sz="1400" b="0">
+                <a:solidFill>
+                  <a:srgbClr val="E0E0E0"/>
+                </a:solidFill>
+                <a:latin typeface="Calibri"/>
+              </a:rPr>
+              <a:t>Auto-fires on data answers.</a:t>
+            </a:r>
+          </a:p>
+          <a:p>
+            <a:pPr algn="l"/>
+            <a:r>
+              <a:rPr sz="1400" b="0">
+                <a:solidFill>
+                  <a:srgbClr val="E0E0E0"/>
+                </a:solidFill>
+                <a:latin typeface="Calibri"/>
+              </a:rPr>
+              <a:t>Plotly dark-theme charts</a:t>
+            </a:r>
+          </a:p>
+        </p:txBody>
+      </p:sp>
+      <p:sp>
+        <p:nvSpPr>
+          <p:cNvPr id="18" name="Rounded Rectangle 17"/>
+          <p:cNvSpPr/>
+          <p:nvPr/>
+        </p:nvSpPr>
+        <p:spPr>
+          <a:xfrm>
+            <a:off x="777240" y="4114800"/>
+            <a:ext cx="3657600" cy="2240280"/>
+          </a:xfrm>
+          <a:prstGeom prst="roundRect">
+            <a:avLst>
+              <a:gd name="adj" fmla="val 8000"/>
+            </a:avLst>
+          </a:prstGeom>
+          <a:solidFill>
+            <a:srgbClr val="16213E"/>
+          </a:solidFill>
+          <a:ln>
+            <a:noFill/>
+          </a:ln>
+          <a:effectLst/>
+        </p:spPr>
+        <p:style>
+          <a:lnRef idx="1">
+            <a:schemeClr val="accent1"/>
+          </a:lnRef>
+          <a:fillRef idx="3">
+            <a:schemeClr val="accent1"/>
+          </a:fillRef>
+          <a:effectRef idx="2">
+            <a:schemeClr val="accent1"/>
+          </a:effectRef>
+          <a:fontRef idx="minor">
+            <a:schemeClr val="lt1"/>
+          </a:fontRef>
+        </p:style>
+        <p:txBody>
+          <a:bodyPr rtlCol="0" anchor="ctr"/>
+          <a:lstStyle/>
+          <a:p>
+            <a:pPr algn="ctr"/>
+          </a:p>
+        </p:txBody>
+      </p:sp>
+      <p:sp>
+        <p:nvSpPr>
+          <p:cNvPr id="19" name="Rectangle 18"/>
+          <p:cNvSpPr/>
+          <p:nvPr/>
+        </p:nvSpPr>
+        <p:spPr>
+          <a:xfrm>
+            <a:off x="777240" y="4114800"/>
+            <a:ext cx="3657600" cy="109728"/>
+          </a:xfrm>
+          <a:prstGeom prst="rect">
+            <a:avLst/>
+          </a:prstGeom>
+          <a:solidFill>
+            <a:srgbClr val="FFD93D"/>
+          </a:solidFill>
+          <a:ln>
+            <a:noFill/>
+          </a:ln>
+        </p:spPr>
+        <p:style>
+          <a:lnRef idx="1">
+            <a:schemeClr val="accent1"/>
+          </a:lnRef>
+          <a:fillRef idx="3">
+            <a:schemeClr val="accent1"/>
+          </a:fillRef>
+          <a:effectRef idx="2">
+            <a:schemeClr val="accent1"/>
+          </a:effectRef>
+          <a:fontRef idx="minor">
+            <a:schemeClr val="lt1"/>
+          </a:fontRef>
+        </p:style>
+        <p:txBody>
+          <a:bodyPr rtlCol="0" anchor="ctr"/>
+          <a:lstStyle/>
+          <a:p>
+            <a:pPr algn="ctr"/>
+          </a:p>
+        </p:txBody>
+      </p:sp>
+      <p:sp>
+        <p:nvSpPr>
+          <p:cNvPr id="20" name="TextBox 19"/>
+          <p:cNvSpPr txBox="1"/>
+          <p:nvPr/>
+        </p:nvSpPr>
+        <p:spPr>
+          <a:xfrm>
+            <a:off x="1005840" y="4389120"/>
+            <a:ext cx="3200400" cy="457200"/>
+          </a:xfrm>
+          <a:prstGeom prst="rect">
+            <a:avLst/>
+          </a:prstGeom>
+          <a:noFill/>
+        </p:spPr>
+        <p:txBody>
+          <a:bodyPr wrap="square" lIns="0" rIns="0" tIns="0" bIns="0">
+            <a:spAutoFit/>
+          </a:bodyPr>
+          <a:lstStyle/>
+          <a:p>
+            <a:pPr algn="l"/>
+            <a:r>
+              <a:rPr sz="1800" b="1">
+                <a:solidFill>
+                  <a:srgbClr val="FFFFFF"/>
+                </a:solidFill>
+                <a:latin typeface="Consolas"/>
+              </a:rPr>
+              <a:t>create-report</a:t>
+            </a:r>
+          </a:p>
+        </p:txBody>
+      </p:sp>
+      <p:sp>
+        <p:nvSpPr>
+          <p:cNvPr id="21" name="TextBox 20"/>
+          <p:cNvSpPr txBox="1"/>
+          <p:nvPr/>
+        </p:nvSpPr>
+        <p:spPr>
+          <a:xfrm>
+            <a:off x="1005840" y="4983480"/>
+            <a:ext cx="3200400" cy="1188720"/>
+          </a:xfrm>
+          <a:prstGeom prst="rect">
+            <a:avLst/>
+          </a:prstGeom>
+          <a:noFill/>
+        </p:spPr>
+        <p:txBody>
+          <a:bodyPr wrap="square" lIns="0" rIns="0" tIns="0" bIns="0">
+            <a:spAutoFit/>
+          </a:bodyPr>
+          <a:lstStyle/>
+          <a:p>
+            <a:pPr algn="l"/>
+            <a:r>
+              <a:rPr sz="1400" b="0">
+                <a:solidFill>
+                  <a:srgbClr val="E0E0E0"/>
+                </a:solidFill>
+                <a:latin typeface="Calibri"/>
+              </a:rPr>
+              <a:t>HTML / PNG / CSV reports</a:t>
+            </a:r>
+          </a:p>
+          <a:p>
+            <a:pPr algn="l"/>
+            <a:r>
+              <a:rPr sz="1400" b="0">
+                <a:solidFill>
+                  <a:srgbClr val="E0E0E0"/>
+                </a:solidFill>
+                <a:latin typeface="Calibri"/>
+              </a:rPr>
+              <a:t>persisted to the sidebar</a:t>
+            </a:r>
+          </a:p>
+        </p:txBody>
+      </p:sp>
+      <p:sp>
+        <p:nvSpPr>
+          <p:cNvPr id="22" name="Rounded Rectangle 21"/>
+          <p:cNvSpPr/>
+          <p:nvPr/>
+        </p:nvSpPr>
+        <p:spPr>
+          <a:xfrm>
+            <a:off x="4663440" y="4114800"/>
+            <a:ext cx="3657600" cy="2240280"/>
+          </a:xfrm>
+          <a:prstGeom prst="roundRect">
+            <a:avLst>
+              <a:gd name="adj" fmla="val 8000"/>
+            </a:avLst>
+          </a:prstGeom>
+          <a:solidFill>
+            <a:srgbClr val="16213E"/>
+          </a:solidFill>
+          <a:ln>
+            <a:noFill/>
+          </a:ln>
+          <a:effectLst/>
+        </p:spPr>
+        <p:style>
+          <a:lnRef idx="1">
+            <a:schemeClr val="accent1"/>
+          </a:lnRef>
+          <a:fillRef idx="3">
+            <a:schemeClr val="accent1"/>
+          </a:fillRef>
+          <a:effectRef idx="2">
+            <a:schemeClr val="accent1"/>
+          </a:effectRef>
+          <a:fontRef idx="minor">
+            <a:schemeClr val="lt1"/>
+          </a:fontRef>
+        </p:style>
+        <p:txBody>
+          <a:bodyPr rtlCol="0" anchor="ctr"/>
+          <a:lstStyle/>
+          <a:p>
+            <a:pPr algn="ctr"/>
+          </a:p>
+        </p:txBody>
+      </p:sp>
+      <p:sp>
+        <p:nvSpPr>
+          <p:cNvPr id="23" name="Rectangle 22"/>
+          <p:cNvSpPr/>
+          <p:nvPr/>
+        </p:nvSpPr>
+        <p:spPr>
+          <a:xfrm>
+            <a:off x="4663440" y="4114800"/>
+            <a:ext cx="3657600" cy="109728"/>
+          </a:xfrm>
+          <a:prstGeom prst="rect">
+            <a:avLst/>
+          </a:prstGeom>
+          <a:solidFill>
+            <a:srgbClr val="6BCB77"/>
+          </a:solidFill>
+          <a:ln>
+            <a:noFill/>
+          </a:ln>
+        </p:spPr>
+        <p:style>
+          <a:lnRef idx="1">
+            <a:schemeClr val="accent1"/>
+          </a:lnRef>
+          <a:fillRef idx="3">
+            <a:schemeClr val="accent1"/>
+          </a:fillRef>
+          <a:effectRef idx="2">
+            <a:schemeClr val="accent1"/>
+          </a:effectRef>
+          <a:fontRef idx="minor">
+            <a:schemeClr val="lt1"/>
+          </a:fontRef>
+        </p:style>
+        <p:txBody>
+          <a:bodyPr rtlCol="0" anchor="ctr"/>
+          <a:lstStyle/>
+          <a:p>
+            <a:pPr algn="ctr"/>
+          </a:p>
+        </p:txBody>
+      </p:sp>
+      <p:sp>
+        <p:nvSpPr>
+          <p:cNvPr id="24" name="TextBox 23"/>
+          <p:cNvSpPr txBox="1"/>
+          <p:nvPr/>
+        </p:nvSpPr>
+        <p:spPr>
+          <a:xfrm>
+            <a:off x="4892040" y="4389120"/>
+            <a:ext cx="3200400" cy="457200"/>
+          </a:xfrm>
+          <a:prstGeom prst="rect">
+            <a:avLst/>
+          </a:prstGeom>
+          <a:noFill/>
+        </p:spPr>
+        <p:txBody>
+          <a:bodyPr wrap="square" lIns="0" rIns="0" tIns="0" bIns="0">
+            <a:spAutoFit/>
+          </a:bodyPr>
+          <a:lstStyle/>
+          <a:p>
+            <a:pPr algn="l"/>
+            <a:r>
+              <a:rPr sz="1800" b="1">
+                <a:solidFill>
+                  <a:srgbClr val="FFFFFF"/>
+                </a:solidFill>
+                <a:latin typeface="Consolas"/>
+              </a:rPr>
+              <a:t>311-resolution-rate</a:t>
+            </a:r>
+          </a:p>
+        </p:txBody>
+      </p:sp>
+      <p:sp>
+        <p:nvSpPr>
+          <p:cNvPr id="25" name="TextBox 24"/>
+          <p:cNvSpPr txBox="1"/>
+          <p:nvPr/>
+        </p:nvSpPr>
+        <p:spPr>
+          <a:xfrm>
+            <a:off x="4892040" y="4983480"/>
+            <a:ext cx="3200400" cy="1188720"/>
+          </a:xfrm>
+          <a:prstGeom prst="rect">
+            <a:avLst/>
+          </a:prstGeom>
+          <a:noFill/>
+        </p:spPr>
+        <p:txBody>
+          <a:bodyPr wrap="square" lIns="0" rIns="0" tIns="0" bIns="0">
+            <a:spAutoFit/>
+          </a:bodyPr>
+          <a:lstStyle/>
+          <a:p>
+            <a:pPr algn="l"/>
+            <a:r>
+              <a:rPr sz="1400" b="0">
+                <a:solidFill>
+                  <a:srgbClr val="E0E0E0"/>
+                </a:solidFill>
+                <a:latin typeface="Calibri"/>
+              </a:rPr>
+              <a:t>Slash command.</a:t>
+            </a:r>
+          </a:p>
+          <a:p>
+            <a:pPr algn="l"/>
+            <a:r>
+              <a:rPr sz="1400" b="0">
+                <a:solidFill>
+                  <a:srgbClr val="E0E0E0"/>
+                </a:solidFill>
+                <a:latin typeface="Calibri"/>
+              </a:rPr>
+              <a:t>Historical resolution %</a:t>
+            </a:r>
+          </a:p>
+        </p:txBody>
+      </p:sp>
+      <p:sp>
+        <p:nvSpPr>
+          <p:cNvPr id="26" name="Rounded Rectangle 25"/>
+          <p:cNvSpPr/>
+          <p:nvPr/>
+        </p:nvSpPr>
+        <p:spPr>
+          <a:xfrm>
+            <a:off x="8549640" y="4114800"/>
+            <a:ext cx="3657600" cy="2240280"/>
+          </a:xfrm>
+          <a:prstGeom prst="roundRect">
+            <a:avLst>
+              <a:gd name="adj" fmla="val 8000"/>
+            </a:avLst>
+          </a:prstGeom>
+          <a:solidFill>
+            <a:srgbClr val="16213E"/>
+          </a:solidFill>
+          <a:ln>
+            <a:noFill/>
+          </a:ln>
+          <a:effectLst/>
+        </p:spPr>
+        <p:style>
+          <a:lnRef idx="1">
+            <a:schemeClr val="accent1"/>
+          </a:lnRef>
+          <a:fillRef idx="3">
+            <a:schemeClr val="accent1"/>
+          </a:fillRef>
+          <a:effectRef idx="2">
+            <a:schemeClr val="accent1"/>
+          </a:effectRef>
+          <a:fontRef idx="minor">
+            <a:schemeClr val="lt1"/>
+          </a:fontRef>
+        </p:style>
+        <p:txBody>
+          <a:bodyPr rtlCol="0" anchor="ctr"/>
+          <a:lstStyle/>
+          <a:p>
+            <a:pPr algn="ctr"/>
+          </a:p>
+        </p:txBody>
+      </p:sp>
+      <p:sp>
+        <p:nvSpPr>
+          <p:cNvPr id="27" name="Rectangle 26"/>
+          <p:cNvSpPr/>
+          <p:nvPr/>
+        </p:nvSpPr>
+        <p:spPr>
+          <a:xfrm>
+            <a:off x="8549640" y="4114800"/>
+            <a:ext cx="3657600" cy="109728"/>
+          </a:xfrm>
+          <a:prstGeom prst="rect">
+            <a:avLst/>
+          </a:prstGeom>
+          <a:solidFill>
+            <a:srgbClr val="00D2FF"/>
+          </a:solidFill>
+          <a:ln>
+            <a:noFill/>
+          </a:ln>
+        </p:spPr>
+        <p:style>
+          <a:lnRef idx="1">
+            <a:schemeClr val="accent1"/>
+          </a:lnRef>
+          <a:fillRef idx="3">
+            <a:schemeClr val="accent1"/>
+          </a:fillRef>
+          <a:effectRef idx="2">
+            <a:schemeClr val="accent1"/>
+          </a:effectRef>
+          <a:fontRef idx="minor">
+            <a:schemeClr val="lt1"/>
+          </a:fontRef>
+        </p:style>
+        <p:txBody>
+          <a:bodyPr rtlCol="0" anchor="ctr"/>
+          <a:lstStyle/>
+          <a:p>
+            <a:pPr algn="ctr"/>
+          </a:p>
+        </p:txBody>
+      </p:sp>
+      <p:sp>
+        <p:nvSpPr>
+          <p:cNvPr id="28" name="TextBox 27"/>
+          <p:cNvSpPr txBox="1"/>
+          <p:nvPr/>
+        </p:nvSpPr>
+        <p:spPr>
+          <a:xfrm>
+            <a:off x="8778240" y="4389120"/>
+            <a:ext cx="3200400" cy="457200"/>
+          </a:xfrm>
+          <a:prstGeom prst="rect">
+            <a:avLst/>
+          </a:prstGeom>
+          <a:noFill/>
+        </p:spPr>
+        <p:txBody>
+          <a:bodyPr wrap="square" lIns="0" rIns="0" tIns="0" bIns="0">
+            <a:spAutoFit/>
+          </a:bodyPr>
+          <a:lstStyle/>
+          <a:p>
+            <a:pPr algn="l"/>
+            <a:r>
+              <a:rPr sz="1800" b="1">
+                <a:solidFill>
+                  <a:srgbClr val="FFFFFF"/>
+                </a:solidFill>
+                <a:latin typeface="Consolas"/>
+              </a:rPr>
+              <a:t>estimate-complaint</a:t>
+            </a:r>
+          </a:p>
+        </p:txBody>
+      </p:sp>
+      <p:sp>
+        <p:nvSpPr>
+          <p:cNvPr id="29" name="TextBox 28"/>
+          <p:cNvSpPr txBox="1"/>
+          <p:nvPr/>
+        </p:nvSpPr>
+        <p:spPr>
+          <a:xfrm>
+            <a:off x="8778240" y="4983480"/>
+            <a:ext cx="3200400" cy="1188720"/>
+          </a:xfrm>
+          <a:prstGeom prst="rect">
+            <a:avLst/>
+          </a:prstGeom>
+          <a:noFill/>
+        </p:spPr>
+        <p:txBody>
+          <a:bodyPr wrap="square" lIns="0" rIns="0" tIns="0" bIns="0">
+            <a:spAutoFit/>
+          </a:bodyPr>
+          <a:lstStyle/>
+          <a:p>
+            <a:pPr algn="l"/>
+            <a:r>
+              <a:rPr sz="1400" b="0">
+                <a:solidFill>
+                  <a:srgbClr val="E0E0E0"/>
+                </a:solidFill>
+                <a:latin typeface="Calibri"/>
+              </a:rPr>
+              <a:t>Slash command.</a:t>
+            </a:r>
+          </a:p>
+          <a:p>
+            <a:pPr algn="l"/>
+            <a:r>
+              <a:rPr sz="1400" b="0">
+                <a:solidFill>
+                  <a:srgbClr val="E0E0E0"/>
+                </a:solidFill>
+                <a:latin typeface="Calibri"/>
+              </a:rPr>
+              <a:t>Severity / complexity estimate</a:t>
+            </a:r>
+          </a:p>
+        </p:txBody>
+      </p:sp>
+      <p:sp>
+        <p:nvSpPr>
+          <p:cNvPr id="30" name="TextBox 29"/>
+          <p:cNvSpPr txBox="1"/>
+          <p:nvPr/>
+        </p:nvSpPr>
+        <p:spPr>
+          <a:xfrm>
+            <a:off x="548640" y="6446520"/>
+            <a:ext cx="3657600" cy="274320"/>
+          </a:xfrm>
+          <a:prstGeom prst="rect">
+            <a:avLst/>
+          </a:prstGeom>
+          <a:noFill/>
+        </p:spPr>
+        <p:txBody>
+          <a:bodyPr wrap="square" lIns="0" rIns="0" tIns="0" bIns="0">
+            <a:spAutoFit/>
+          </a:bodyPr>
+          <a:lstStyle/>
+          <a:p>
+            <a:pPr algn="l"/>
+            <a:r>
+              <a:rPr sz="1000" b="0">
+                <a:solidFill>
+                  <a:srgbClr val="9999AA"/>
+                </a:solidFill>
+                <a:latin typeface="Calibri"/>
+              </a:rPr>
+              <a:t>Agent Austin</a:t>
+            </a:r>
+          </a:p>
+        </p:txBody>
+      </p:sp>
+      <p:sp>
+        <p:nvSpPr>
+          <p:cNvPr id="31" name="TextBox 30"/>
+          <p:cNvSpPr txBox="1"/>
+          <p:nvPr/>
+        </p:nvSpPr>
+        <p:spPr>
+          <a:xfrm>
+            <a:off x="10972800" y="6446520"/>
+            <a:ext cx="731520" cy="274320"/>
+          </a:xfrm>
+          <a:prstGeom prst="rect">
+            <a:avLst/>
+          </a:prstGeom>
+          <a:noFill/>
+        </p:spPr>
+        <p:txBody>
+          <a:bodyPr wrap="square" lIns="0" rIns="0" tIns="0" bIns="0">
+            <a:spAutoFit/>
+          </a:bodyPr>
+          <a:lstStyle/>
+          <a:p>
+            <a:pPr algn="r"/>
+            <a:r>
+              <a:rPr sz="1000" b="0">
+                <a:solidFill>
+                  <a:srgbClr val="9999AA"/>
+                </a:solidFill>
+                <a:latin typeface="Calibri"/>
+              </a:rPr>
+              <a:t>5 / 6</a:t>
+            </a:r>
+          </a:p>
+        </p:txBody>
+      </p:sp>
+    </p:spTree>
+  </p:cSld>
+  <p:clrMapOvr>
+    <a:masterClrMapping/>
+  </p:clrMapOvr>
+</p:sld>
+</file>
+
+<file path=ppt/slides/slide6.xml><?xml version="1.0" encoding="utf-8"?>
+<p:sld xmlns:a="http://schemas.openxmlformats.org/drawingml/2006/main" xmlns:p="http://schemas.openxmlformats.org/presentationml/2006/main" xmlns:r="http://schemas.openxmlformats.org/officeDocument/2006/relationships">
+  <p:cSld>
+    <p:spTree>
+      <p:nvGrpSpPr>
+        <p:cNvPr id="1" name=""/>
+        <p:cNvGrpSpPr/>
+        <p:nvPr/>
+      </p:nvGrpSpPr>
+      <p:grpSpPr/>
+      <p:sp>
+        <p:nvSpPr>
+          <p:cNvPr id="2" name="Rectangle 1"/>
+          <p:cNvSpPr/>
+          <p:nvPr/>
+        </p:nvSpPr>
+        <p:spPr>
+          <a:xfrm>
+            <a:off x="0" y="0"/>
+            <a:ext cx="12191695" cy="6858000"/>
+          </a:xfrm>
+          <a:prstGeom prst="rect">
+            <a:avLst/>
+          </a:prstGeom>
+          <a:solidFill>
+            <a:srgbClr val="1A1A2E"/>
+          </a:solidFill>
+          <a:ln>
+            <a:noFill/>
+          </a:ln>
+          <a:effectLst/>
+        </p:spPr>
+        <p:style>
+          <a:lnRef idx="1">
+            <a:schemeClr val="accent1"/>
+          </a:lnRef>
+          <a:fillRef idx="3">
+            <a:schemeClr val="accent1"/>
+          </a:fillRef>
+          <a:effectRef idx="2">
+            <a:schemeClr val="accent1"/>
+          </a:effectRef>
+          <a:fontRef idx="minor">
+            <a:schemeClr val="lt1"/>
+          </a:fontRef>
+        </p:style>
+        <p:txBody>
+          <a:bodyPr rtlCol="0" anchor="ctr"/>
+          <a:lstStyle/>
+          <a:p>
+            <a:pPr algn="ctr"/>
+          </a:p>
+        </p:txBody>
+      </p:sp>
+      <p:sp>
+        <p:nvSpPr>
+          <p:cNvPr id="3" name="Rectangle 2"/>
+          <p:cNvSpPr/>
+          <p:nvPr/>
+        </p:nvSpPr>
+        <p:spPr>
+          <a:xfrm>
+            <a:off x="548640" y="548640"/>
+            <a:ext cx="109728" cy="457200"/>
+          </a:xfrm>
+          <a:prstGeom prst="rect">
+            <a:avLst/>
+          </a:prstGeom>
+          <a:solidFill>
+            <a:srgbClr val="7B2FF7"/>
+          </a:solidFill>
+          <a:ln>
+            <a:noFill/>
+          </a:ln>
+        </p:spPr>
+        <p:style>
+          <a:lnRef idx="1">
+            <a:schemeClr val="accent1"/>
+          </a:lnRef>
+          <a:fillRef idx="3">
+            <a:schemeClr val="accent1"/>
+          </a:fillRef>
+          <a:effectRef idx="2">
+            <a:schemeClr val="accent1"/>
+          </a:effectRef>
+          <a:fontRef idx="minor">
+            <a:schemeClr val="lt1"/>
+          </a:fontRef>
+        </p:style>
+        <p:txBody>
+          <a:bodyPr rtlCol="0" anchor="ctr"/>
+          <a:lstStyle/>
+          <a:p>
+            <a:pPr algn="ctr"/>
+          </a:p>
+        </p:txBody>
+      </p:sp>
+      <p:sp>
+        <p:nvSpPr>
+          <p:cNvPr id="4" name="TextBox 3"/>
+          <p:cNvSpPr txBox="1"/>
+          <p:nvPr/>
+        </p:nvSpPr>
+        <p:spPr>
+          <a:xfrm>
+            <a:off x="777240" y="502920"/>
+            <a:ext cx="10972800" cy="640080"/>
+          </a:xfrm>
+          <a:prstGeom prst="rect">
+            <a:avLst/>
+          </a:prstGeom>
+          <a:noFill/>
+        </p:spPr>
+        <p:txBody>
+          <a:bodyPr wrap="square" lIns="0" rIns="0" tIns="0" bIns="0">
+            <a:spAutoFit/>
+          </a:bodyPr>
+          <a:lstStyle/>
+          <a:p>
+            <a:pPr algn="l"/>
+            <a:r>
+              <a:rPr sz="3600" b="1">
+                <a:solidFill>
+                  <a:srgbClr val="FFFFFF"/>
+                </a:solidFill>
+                <a:latin typeface="Calibri"/>
+              </a:rPr>
+              <a:t>Skills in detail</a:t>
+            </a:r>
+          </a:p>
+        </p:txBody>
+      </p:sp>
+      <p:sp>
+        <p:nvSpPr>
+          <p:cNvPr id="5" name="Oval 4"/>
+          <p:cNvSpPr/>
+          <p:nvPr/>
+        </p:nvSpPr>
+        <p:spPr>
+          <a:xfrm>
+            <a:off x="777240" y="1527048"/>
+            <a:ext cx="320040" cy="320040"/>
+          </a:xfrm>
+          <a:prstGeom prst="ellipse">
+            <a:avLst/>
+          </a:prstGeom>
+          <a:solidFill>
+            <a:srgbClr val="00D2FF"/>
+          </a:solidFill>
+          <a:ln>
+            <a:noFill/>
+          </a:ln>
+        </p:spPr>
+        <p:style>
+          <a:lnRef idx="1">
+            <a:schemeClr val="accent1"/>
+          </a:lnRef>
+          <a:fillRef idx="3">
+            <a:schemeClr val="accent1"/>
+          </a:fillRef>
+          <a:effectRef idx="2">
+            <a:schemeClr val="accent1"/>
+          </a:effectRef>
+          <a:fontRef idx="minor">
+            <a:schemeClr val="lt1"/>
+          </a:fontRef>
+        </p:style>
+        <p:txBody>
+          <a:bodyPr rtlCol="0" anchor="ctr"/>
+          <a:lstStyle/>
+          <a:p>
+            <a:pPr algn="ctr"/>
+          </a:p>
+        </p:txBody>
+      </p:sp>
+      <p:sp>
+        <p:nvSpPr>
+          <p:cNvPr id="6" name="TextBox 5"/>
+          <p:cNvSpPr txBox="1"/>
+          <p:nvPr/>
+        </p:nvSpPr>
+        <p:spPr>
+          <a:xfrm>
+            <a:off x="1234440" y="1417320"/>
+            <a:ext cx="2651760" cy="411480"/>
+          </a:xfrm>
+          <a:prstGeom prst="rect">
+            <a:avLst/>
+          </a:prstGeom>
+          <a:noFill/>
+        </p:spPr>
+        <p:txBody>
+          <a:bodyPr wrap="square" lIns="0" rIns="0" tIns="0" bIns="0">
+            <a:spAutoFit/>
+          </a:bodyPr>
+          <a:lstStyle/>
+          <a:p>
+            <a:pPr algn="l"/>
+            <a:r>
+              <a:rPr sz="1600" b="1">
+                <a:solidFill>
+                  <a:srgbClr val="FFFFFF"/>
+                </a:solidFill>
+                <a:latin typeface="Consolas"/>
+              </a:rPr>
+              <a:t>download-311-data</a:t>
+            </a:r>
+          </a:p>
+        </p:txBody>
+      </p:sp>
+      <p:sp>
+        <p:nvSpPr>
+          <p:cNvPr id="7" name="TextBox 6"/>
+          <p:cNvSpPr txBox="1"/>
+          <p:nvPr/>
+        </p:nvSpPr>
+        <p:spPr>
+          <a:xfrm>
+            <a:off x="3931920" y="1435608"/>
+            <a:ext cx="7772400" cy="685800"/>
+          </a:xfrm>
+          <a:prstGeom prst="rect">
+            <a:avLst/>
+          </a:prstGeom>
+          <a:noFill/>
+        </p:spPr>
+        <p:txBody>
+          <a:bodyPr wrap="square" lIns="0" rIns="0" tIns="0" bIns="0">
+            <a:spAutoFit/>
+          </a:bodyPr>
+          <a:lstStyle/>
+          <a:p>
+            <a:pPr algn="l"/>
+            <a:r>
+              <a:rPr sz="1300" b="0">
+                <a:solidFill>
+                  <a:srgbClr val="E0E0E0"/>
+                </a:solidFill>
+                <a:latin typeface="Calibri"/>
+              </a:rPr>
+              <a:t>Socrata dataset xwdj-i9he → 311_recent.csv. 100k rows/page. Full download or delta-merge by sr_number.</a:t>
+            </a:r>
+          </a:p>
+        </p:txBody>
+      </p:sp>
+      <p:sp>
+        <p:nvSpPr>
+          <p:cNvPr id="8" name="Oval 7"/>
+          <p:cNvSpPr/>
+          <p:nvPr/>
+        </p:nvSpPr>
+        <p:spPr>
+          <a:xfrm>
+            <a:off x="777240" y="2368296"/>
+            <a:ext cx="320040" cy="320040"/>
+          </a:xfrm>
+          <a:prstGeom prst="ellipse">
+            <a:avLst/>
+          </a:prstGeom>
+          <a:solidFill>
+            <a:srgbClr val="7B2FF7"/>
+          </a:solidFill>
+          <a:ln>
+            <a:noFill/>
+          </a:ln>
+        </p:spPr>
+        <p:style>
+          <a:lnRef idx="1">
+            <a:schemeClr val="accent1"/>
+          </a:lnRef>
+          <a:fillRef idx="3">
+            <a:schemeClr val="accent1"/>
+          </a:fillRef>
+          <a:effectRef idx="2">
+            <a:schemeClr val="accent1"/>
+          </a:effectRef>
+          <a:fontRef idx="minor">
+            <a:schemeClr val="lt1"/>
+          </a:fontRef>
+        </p:style>
+        <p:txBody>
+          <a:bodyPr rtlCol="0" anchor="ctr"/>
+          <a:lstStyle/>
+          <a:p>
+            <a:pPr algn="ctr"/>
+          </a:p>
+        </p:txBody>
+      </p:sp>
+      <p:sp>
+        <p:nvSpPr>
+          <p:cNvPr id="9" name="TextBox 8"/>
+          <p:cNvSpPr txBox="1"/>
+          <p:nvPr/>
+        </p:nvSpPr>
+        <p:spPr>
+          <a:xfrm>
+            <a:off x="1234440" y="2258568"/>
+            <a:ext cx="2651760" cy="411480"/>
+          </a:xfrm>
+          <a:prstGeom prst="rect">
+            <a:avLst/>
+          </a:prstGeom>
+          <a:noFill/>
+        </p:spPr>
+        <p:txBody>
+          <a:bodyPr wrap="square" lIns="0" rIns="0" tIns="0" bIns="0">
+            <a:spAutoFit/>
+          </a:bodyPr>
+          <a:lstStyle/>
+          <a:p>
+            <a:pPr algn="l"/>
+            <a:r>
+              <a:rPr sz="1600" b="1">
+                <a:solidFill>
+                  <a:srgbClr val="FFFFFF"/>
+                </a:solidFill>
+                <a:latin typeface="Consolas"/>
+              </a:rPr>
+              <a:t>analyze-311-data</a:t>
+            </a:r>
+          </a:p>
+        </p:txBody>
+      </p:sp>
+      <p:sp>
+        <p:nvSpPr>
+          <p:cNvPr id="10" name="TextBox 9"/>
+          <p:cNvSpPr txBox="1"/>
+          <p:nvPr/>
+        </p:nvSpPr>
+        <p:spPr>
+          <a:xfrm>
+            <a:off x="3931920" y="2276856"/>
+            <a:ext cx="7772400" cy="685800"/>
+          </a:xfrm>
+          <a:prstGeom prst="rect">
+            <a:avLst/>
+          </a:prstGeom>
+          <a:noFill/>
+        </p:spPr>
+        <p:txBody>
+          <a:bodyPr wrap="square" lIns="0" rIns="0" tIns="0" bIns="0">
+            <a:spAutoFit/>
+          </a:bodyPr>
+          <a:lstStyle/>
+          <a:p>
+            <a:pPr algn="l"/>
+            <a:r>
+              <a:rPr sz="1300" b="0">
+                <a:solidFill>
+                  <a:srgbClr val="E0E0E0"/>
+                </a:solidFill>
+                <a:latin typeface="Calibri"/>
+              </a:rPr>
+              <a:t>Top types, departments, status mix, day/hour patterns, ZIPs, districts, resolution times, open backlog, 7-day ASCII bar chart.</a:t>
+            </a:r>
+          </a:p>
+        </p:txBody>
+      </p:sp>
+      <p:sp>
+        <p:nvSpPr>
+          <p:cNvPr id="11" name="Oval 10"/>
+          <p:cNvSpPr/>
+          <p:nvPr/>
+        </p:nvSpPr>
+        <p:spPr>
+          <a:xfrm>
+            <a:off x="777240" y="3209544"/>
+            <a:ext cx="320040" cy="320040"/>
+          </a:xfrm>
+          <a:prstGeom prst="ellipse">
+            <a:avLst/>
+          </a:prstGeom>
+          <a:solidFill>
+            <a:srgbClr val="FF6B6B"/>
+          </a:solidFill>
+          <a:ln>
+            <a:noFill/>
+          </a:ln>
+        </p:spPr>
+        <p:style>
+          <a:lnRef idx="1">
+            <a:schemeClr val="accent1"/>
+          </a:lnRef>
+          <a:fillRef idx="3">
+            <a:schemeClr val="accent1"/>
+          </a:fillRef>
+          <a:effectRef idx="2">
+            <a:schemeClr val="accent1"/>
+          </a:effectRef>
+          <a:fontRef idx="minor">
+            <a:schemeClr val="lt1"/>
+          </a:fontRef>
+        </p:style>
+        <p:txBody>
+          <a:bodyPr rtlCol="0" anchor="ctr"/>
+          <a:lstStyle/>
+          <a:p>
+            <a:pPr algn="ctr"/>
+          </a:p>
+        </p:txBody>
+      </p:sp>
+      <p:sp>
+        <p:nvSpPr>
+          <p:cNvPr id="12" name="TextBox 11"/>
+          <p:cNvSpPr txBox="1"/>
+          <p:nvPr/>
+        </p:nvSpPr>
+        <p:spPr>
+          <a:xfrm>
+            <a:off x="1234440" y="3099816"/>
+            <a:ext cx="2651760" cy="411480"/>
+          </a:xfrm>
+          <a:prstGeom prst="rect">
+            <a:avLst/>
+          </a:prstGeom>
+          <a:noFill/>
+        </p:spPr>
+        <p:txBody>
+          <a:bodyPr wrap="square" lIns="0" rIns="0" tIns="0" bIns="0">
+            <a:spAutoFit/>
+          </a:bodyPr>
+          <a:lstStyle/>
+          <a:p>
+            <a:pPr algn="l"/>
+            <a:r>
+              <a:rPr sz="1600" b="1">
+                <a:solidFill>
+                  <a:srgbClr val="FFFFFF"/>
+                </a:solidFill>
+                <a:latin typeface="Consolas"/>
+              </a:rPr>
+              <a:t>visualize</a:t>
+            </a:r>
+          </a:p>
+        </p:txBody>
+      </p:sp>
+      <p:sp>
+        <p:nvSpPr>
+          <p:cNvPr id="13" name="TextBox 12"/>
+          <p:cNvSpPr txBox="1"/>
+          <p:nvPr/>
+        </p:nvSpPr>
+        <p:spPr>
+          <a:xfrm>
+            <a:off x="3931920" y="3118104"/>
+            <a:ext cx="7772400" cy="685800"/>
+          </a:xfrm>
+          <a:prstGeom prst="rect">
+            <a:avLst/>
+          </a:prstGeom>
+          <a:noFill/>
+        </p:spPr>
+        <p:txBody>
+          <a:bodyPr wrap="square" lIns="0" rIns="0" tIns="0" bIns="0">
+            <a:spAutoFit/>
+          </a:bodyPr>
+          <a:lstStyle/>
+          <a:p>
+            <a:pPr algn="l"/>
+            <a:r>
+              <a:rPr sz="1300" b="0">
+                <a:solidFill>
+                  <a:srgbClr val="E0E0E0"/>
+                </a:solidFill>
+                <a:latin typeface="Calibri"/>
+              </a:rPr>
+              <a:t>Automatic on any data answer with ≥3 points. Plotly dark theme, saved via save_chart, rendered in the artifact panel.</a:t>
+            </a:r>
+          </a:p>
+        </p:txBody>
+      </p:sp>
+      <p:sp>
+        <p:nvSpPr>
+          <p:cNvPr id="14" name="Oval 13"/>
+          <p:cNvSpPr/>
+          <p:nvPr/>
+        </p:nvSpPr>
+        <p:spPr>
+          <a:xfrm>
+            <a:off x="777240" y="4050792"/>
+            <a:ext cx="320040" cy="320040"/>
+          </a:xfrm>
+          <a:prstGeom prst="ellipse">
+            <a:avLst/>
+          </a:prstGeom>
+          <a:solidFill>
+            <a:srgbClr val="FFD93D"/>
+          </a:solidFill>
+          <a:ln>
+            <a:noFill/>
+          </a:ln>
+        </p:spPr>
+        <p:style>
+          <a:lnRef idx="1">
+            <a:schemeClr val="accent1"/>
+          </a:lnRef>
+          <a:fillRef idx="3">
+            <a:schemeClr val="accent1"/>
+          </a:fillRef>
+          <a:effectRef idx="2">
+            <a:schemeClr val="accent1"/>
+          </a:effectRef>
+          <a:fontRef idx="minor">
+            <a:schemeClr val="lt1"/>
+          </a:fontRef>
+        </p:style>
+        <p:txBody>
+          <a:bodyPr rtlCol="0" anchor="ctr"/>
+          <a:lstStyle/>
+          <a:p>
+            <a:pPr algn="ctr"/>
+          </a:p>
+        </p:txBody>
+      </p:sp>
+      <p:sp>
+        <p:nvSpPr>
+          <p:cNvPr id="15" name="TextBox 14"/>
+          <p:cNvSpPr txBox="1"/>
+          <p:nvPr/>
+        </p:nvSpPr>
+        <p:spPr>
+          <a:xfrm>
+            <a:off x="1234440" y="3941064"/>
+            <a:ext cx="2651760" cy="411480"/>
+          </a:xfrm>
+          <a:prstGeom prst="rect">
+            <a:avLst/>
+          </a:prstGeom>
+          <a:noFill/>
+        </p:spPr>
+        <p:txBody>
+          <a:bodyPr wrap="square" lIns="0" rIns="0" tIns="0" bIns="0">
+            <a:spAutoFit/>
+          </a:bodyPr>
+          <a:lstStyle/>
+          <a:p>
+            <a:pPr algn="l"/>
+            <a:r>
+              <a:rPr sz="1600" b="1">
+                <a:solidFill>
+                  <a:srgbClr val="FFFFFF"/>
+                </a:solidFill>
+                <a:latin typeface="Consolas"/>
+              </a:rPr>
+              <a:t>create-report</a:t>
+            </a:r>
+          </a:p>
+        </p:txBody>
+      </p:sp>
+      <p:sp>
+        <p:nvSpPr>
+          <p:cNvPr id="16" name="TextBox 15"/>
+          <p:cNvSpPr txBox="1"/>
+          <p:nvPr/>
+        </p:nvSpPr>
+        <p:spPr>
+          <a:xfrm>
+            <a:off x="3931920" y="3959352"/>
+            <a:ext cx="7772400" cy="685800"/>
+          </a:xfrm>
+          <a:prstGeom prst="rect">
+            <a:avLst/>
+          </a:prstGeom>
+          <a:noFill/>
+        </p:spPr>
+        <p:txBody>
+          <a:bodyPr wrap="square" lIns="0" rIns="0" tIns="0" bIns="0">
+            <a:spAutoFit/>
+          </a:bodyPr>
+          <a:lstStyle/>
+          <a:p>
+            <a:pPr algn="l"/>
+            <a:r>
+              <a:rPr sz="1300" b="0">
+                <a:solidFill>
+                  <a:srgbClr val="E0E0E0"/>
+                </a:solidFill>
+                <a:latin typeface="Calibri"/>
+              </a:rPr>
+              <a:t>Self-contained HTML reports with metric cards + Plotly + narrative. Saved via save_report so they appear in the sidebar.</a:t>
+            </a:r>
+          </a:p>
+        </p:txBody>
+      </p:sp>
+      <p:sp>
+        <p:nvSpPr>
+          <p:cNvPr id="17" name="Oval 16"/>
+          <p:cNvSpPr/>
+          <p:nvPr/>
+        </p:nvSpPr>
+        <p:spPr>
+          <a:xfrm>
+            <a:off x="777240" y="4892040"/>
+            <a:ext cx="320040" cy="320040"/>
+          </a:xfrm>
+          <a:prstGeom prst="ellipse">
+            <a:avLst/>
+          </a:prstGeom>
+          <a:solidFill>
+            <a:srgbClr val="6BCB77"/>
+          </a:solidFill>
+          <a:ln>
+            <a:noFill/>
+          </a:ln>
+        </p:spPr>
+        <p:style>
+          <a:lnRef idx="1">
+            <a:schemeClr val="accent1"/>
+          </a:lnRef>
+          <a:fillRef idx="3">
+            <a:schemeClr val="accent1"/>
+          </a:fillRef>
+          <a:effectRef idx="2">
+            <a:schemeClr val="accent1"/>
+          </a:effectRef>
+          <a:fontRef idx="minor">
+            <a:schemeClr val="lt1"/>
+          </a:fontRef>
+        </p:style>
+        <p:txBody>
+          <a:bodyPr rtlCol="0" anchor="ctr"/>
+          <a:lstStyle/>
+          <a:p>
+            <a:pPr algn="ctr"/>
+          </a:p>
+        </p:txBody>
+      </p:sp>
+      <p:sp>
+        <p:nvSpPr>
+          <p:cNvPr id="18" name="TextBox 17"/>
+          <p:cNvSpPr txBox="1"/>
+          <p:nvPr/>
+        </p:nvSpPr>
+        <p:spPr>
+          <a:xfrm>
+            <a:off x="1234440" y="4782312"/>
+            <a:ext cx="2651760" cy="411480"/>
+          </a:xfrm>
+          <a:prstGeom prst="rect">
+            <a:avLst/>
+          </a:prstGeom>
+          <a:noFill/>
+        </p:spPr>
+        <p:txBody>
+          <a:bodyPr wrap="square" lIns="0" rIns="0" tIns="0" bIns="0">
+            <a:spAutoFit/>
+          </a:bodyPr>
+          <a:lstStyle/>
+          <a:p>
+            <a:pPr algn="l"/>
+            <a:r>
+              <a:rPr sz="1600" b="1">
+                <a:solidFill>
+                  <a:srgbClr val="FFFFFF"/>
+                </a:solidFill>
+                <a:latin typeface="Consolas"/>
+              </a:rPr>
+              <a:t>311-resolution-rate</a:t>
+            </a:r>
+          </a:p>
+        </p:txBody>
+      </p:sp>
+      <p:sp>
+        <p:nvSpPr>
+          <p:cNvPr id="19" name="TextBox 18"/>
+          <p:cNvSpPr txBox="1"/>
+          <p:nvPr/>
+        </p:nvSpPr>
+        <p:spPr>
+          <a:xfrm>
+            <a:off x="3931920" y="4800600"/>
+            <a:ext cx="7772400" cy="685800"/>
+          </a:xfrm>
+          <a:prstGeom prst="rect">
+            <a:avLst/>
+          </a:prstGeom>
+          <a:noFill/>
+        </p:spPr>
+        <p:txBody>
+          <a:bodyPr wrap="square" lIns="0" rIns="0" tIns="0" bIns="0">
+            <a:spAutoFit/>
+          </a:bodyPr>
+          <a:lstStyle/>
+          <a:p>
+            <a:pPr algn="l"/>
+            <a:r>
+              <a:rPr sz="1300" b="0">
+                <a:solidFill>
+                  <a:srgbClr val="E0E0E0"/>
+                </a:solidFill>
+                <a:latin typeface="Calibri"/>
+              </a:rPr>
+              <a:t>Matches a complaint to a category and returns resolution %, annual volume, reasons for non-resolution, and tips.</a:t>
+            </a:r>
+          </a:p>
+        </p:txBody>
+      </p:sp>
+      <p:sp>
+        <p:nvSpPr>
+          <p:cNvPr id="20" name="Oval 19"/>
+          <p:cNvSpPr/>
+          <p:nvPr/>
+        </p:nvSpPr>
+        <p:spPr>
+          <a:xfrm>
+            <a:off x="777240" y="5733288"/>
+            <a:ext cx="320040" cy="320040"/>
+          </a:xfrm>
+          <a:prstGeom prst="ellipse">
+            <a:avLst/>
+          </a:prstGeom>
+          <a:solidFill>
+            <a:srgbClr val="00D2FF"/>
+          </a:solidFill>
+          <a:ln>
+            <a:noFill/>
+          </a:ln>
+        </p:spPr>
+        <p:style>
+          <a:lnRef idx="1">
+            <a:schemeClr val="accent1"/>
+          </a:lnRef>
+          <a:fillRef idx="3">
+            <a:schemeClr val="accent1"/>
+          </a:fillRef>
+          <a:effectRef idx="2">
+            <a:schemeClr val="accent1"/>
+          </a:effectRef>
+          <a:fontRef idx="minor">
+            <a:schemeClr val="lt1"/>
+          </a:fontRef>
+        </p:style>
+        <p:txBody>
+          <a:bodyPr rtlCol="0" anchor="ctr"/>
+          <a:lstStyle/>
+          <a:p>
+            <a:pPr algn="ctr"/>
+          </a:p>
+        </p:txBody>
+      </p:sp>
+      <p:sp>
+        <p:nvSpPr>
+          <p:cNvPr id="21" name="TextBox 20"/>
+          <p:cNvSpPr txBox="1"/>
+          <p:nvPr/>
+        </p:nvSpPr>
+        <p:spPr>
+          <a:xfrm>
+            <a:off x="1234440" y="5623560"/>
+            <a:ext cx="2651760" cy="411480"/>
+          </a:xfrm>
+          <a:prstGeom prst="rect">
+            <a:avLst/>
+          </a:prstGeom>
+          <a:noFill/>
+        </p:spPr>
+        <p:txBody>
+          <a:bodyPr wrap="square" lIns="0" rIns="0" tIns="0" bIns="0">
+            <a:spAutoFit/>
+          </a:bodyPr>
+          <a:lstStyle/>
+          <a:p>
+            <a:pPr algn="l"/>
+            <a:r>
+              <a:rPr sz="1600" b="1">
+                <a:solidFill>
+                  <a:srgbClr val="FFFFFF"/>
+                </a:solidFill>
+                <a:latin typeface="Consolas"/>
+              </a:rPr>
+              <a:t>estimate-complaint</a:t>
+            </a:r>
+          </a:p>
+        </p:txBody>
+      </p:sp>
+      <p:sp>
+        <p:nvSpPr>
+          <p:cNvPr id="22" name="TextBox 21"/>
+          <p:cNvSpPr txBox="1"/>
+          <p:nvPr/>
+        </p:nvSpPr>
+        <p:spPr>
+          <a:xfrm>
+            <a:off x="3931920" y="5641848"/>
+            <a:ext cx="7772400" cy="685800"/>
+          </a:xfrm>
+          <a:prstGeom prst="rect">
+            <a:avLst/>
+          </a:prstGeom>
+          <a:noFill/>
+        </p:spPr>
+        <p:txBody>
+          <a:bodyPr wrap="square" lIns="0" rIns="0" tIns="0" bIns="0">
+            <a:spAutoFit/>
+          </a:bodyPr>
+          <a:lstStyle/>
+          <a:p>
+            <a:pPr algn="l"/>
+            <a:r>
+              <a:rPr sz="1300" b="0">
+                <a:solidFill>
+                  <a:srgbClr val="E0E0E0"/>
+                </a:solidFill>
+                <a:latin typeface="Calibri"/>
+              </a:rPr>
+              <a:t>Scores severity × complexity × dependencies × resources and outputs a time estimate with confidence + risks.</a:t>
+            </a:r>
+          </a:p>
+        </p:txBody>
+      </p:sp>
+      <p:sp>
+        <p:nvSpPr>
+          <p:cNvPr id="23" name="TextBox 22"/>
+          <p:cNvSpPr txBox="1"/>
+          <p:nvPr/>
+        </p:nvSpPr>
+        <p:spPr>
+          <a:xfrm>
+            <a:off x="548640" y="6446520"/>
+            <a:ext cx="3657600" cy="274320"/>
+          </a:xfrm>
+          <a:prstGeom prst="rect">
+            <a:avLst/>
+          </a:prstGeom>
+          <a:noFill/>
+        </p:spPr>
+        <p:txBody>
+          <a:bodyPr wrap="square" lIns="0" rIns="0" tIns="0" bIns="0">
+            <a:spAutoFit/>
+          </a:bodyPr>
+          <a:lstStyle/>
+          <a:p>
+            <a:pPr algn="l"/>
+            <a:r>
+              <a:rPr sz="1000" b="0">
+                <a:solidFill>
+                  <a:srgbClr val="9999AA"/>
+                </a:solidFill>
+                <a:latin typeface="Calibri"/>
+              </a:rPr>
+              <a:t>Agent Austin</a:t>
+            </a:r>
+          </a:p>
+        </p:txBody>
+      </p:sp>
+      <p:sp>
+        <p:nvSpPr>
+          <p:cNvPr id="24" name="TextBox 23"/>
+          <p:cNvSpPr txBox="1"/>
+          <p:nvPr/>
+        </p:nvSpPr>
+        <p:spPr>
+          <a:xfrm>
+            <a:off x="10972800" y="6446520"/>
+            <a:ext cx="731520" cy="274320"/>
+          </a:xfrm>
+          <a:prstGeom prst="rect">
+            <a:avLst/>
+          </a:prstGeom>
+          <a:noFill/>
+        </p:spPr>
+        <p:txBody>
+          <a:bodyPr wrap="square" lIns="0" rIns="0" tIns="0" bIns="0">
+            <a:spAutoFit/>
+          </a:bodyPr>
+          <a:lstStyle/>
+          <a:p>
+            <a:pPr algn="r"/>
+            <a:r>
+              <a:rPr sz="1000" b="0">
+                <a:solidFill>
+                  <a:srgbClr val="9999AA"/>
+                </a:solidFill>
+                <a:latin typeface="Calibri"/>
+              </a:rPr>
+              <a:t>6 / 6</a:t>
             </a:r>
           </a:p>
         </p:txBody>

</xml_diff>